<commit_message>
Update presentation deck slides to reflect final MERN and Gemini 2.5 Flash architecture
</commit_message>
<xml_diff>
--- a/AcademixIQ_Pitch_Deck.pptx
+++ b/AcademixIQ_Pitch_Deck.pptx
@@ -3284,7 +3284,7 @@
               </a:defRPr>
             </a:pPr>
             <a:r>
-              <a:t>Team: Team Academix</a:t>
+              <a:t>Team: ayushkhaitan2004</a:t>
             </a:r>
           </a:p>
           <a:p>
@@ -3297,7 +3297,7 @@
               </a:defRPr>
             </a:pPr>
             <a:r>
-              <a:t>Solo Innovator: Ayush Khaitan</a:t>
+              <a:t>Solo Innovator: Ayush Khaitan  |  SRMIST Ghaziabad</a:t>
             </a:r>
           </a:p>
           <a:p>
@@ -3310,7 +3310,7 @@
               </a:defRPr>
             </a:pPr>
             <a:r>
-              <a:t>Themes: EdTech, AI/ML, Accessibility</a:t>
+              <a:t>Themes: EdTech, AI/ML, Accessibility &amp; Inclusion</a:t>
             </a:r>
           </a:p>
         </p:txBody>
@@ -5051,7 +5051,7 @@
               </a:defRPr>
             </a:pPr>
             <a:r>
-              <a:t>• Whisper Large v3 STT</a:t>
+              <a:t>• Web Speech API (SpeechRecognition)</a:t>
             </a:r>
           </a:p>
           <a:p>
@@ -5066,7 +5066,7 @@
               </a:defRPr>
             </a:pPr>
             <a:r>
-              <a:t>• Gemini Pro (JSON/Context Extraction)</a:t>
+              <a:t>• Google Gemini 2.5 Flash SDK</a:t>
             </a:r>
           </a:p>
           <a:p>
@@ -5081,7 +5081,7 @@
               </a:defRPr>
             </a:pPr>
             <a:r>
-              <a:t>• LangChain RAG Search</a:t>
+              <a:t>• Dynamic Node Expansion logic</a:t>
             </a:r>
           </a:p>
           <a:p>
@@ -5096,7 +5096,7 @@
               </a:defRPr>
             </a:pPr>
             <a:r>
-              <a:t>• Speech-to-Speech Engine</a:t>
+              <a:t>• Web Speech API (SpeechSynthesis TTS)</a:t>
             </a:r>
           </a:p>
           <a:p>
@@ -5111,7 +5111,7 @@
               </a:defRPr>
             </a:pPr>
             <a:r>
-              <a:t>• Graph-modeling algorithms</a:t>
+              <a:t>• Express Node.js Backend Server</a:t>
             </a:r>
           </a:p>
         </p:txBody>
@@ -5558,7 +5558,7 @@
               </a:defRPr>
             </a:pPr>
             <a:r>
-              <a:t>Building responsive, highly accessible student portals.</a:t>
+              <a:t>Highly accessible, interactive user interface.</a:t>
             </a:r>
           </a:p>
           <a:p>
@@ -5574,7 +5574,7 @@
               </a:defRPr>
             </a:pPr>
             <a:r>
-              <a:t>• React.js &amp; Redux Toolkit</a:t>
+              <a:t>• React.js &amp; TypeScript</a:t>
             </a:r>
           </a:p>
           <a:p>
@@ -5606,7 +5606,7 @@
               </a:defRPr>
             </a:pPr>
             <a:r>
-              <a:t>• Lucide React Icons</a:t>
+              <a:t>• HTML5 Canvas (VisualMind Graph)</a:t>
             </a:r>
           </a:p>
           <a:p>
@@ -5622,7 +5622,7 @@
               </a:defRPr>
             </a:pPr>
             <a:r>
-              <a:t>• Canvas &amp; D3.js (Mind maps)</a:t>
+              <a:t>• Web Speech API (STT Transcription)</a:t>
             </a:r>
           </a:p>
           <a:p>
@@ -5638,7 +5638,7 @@
               </a:defRPr>
             </a:pPr>
             <a:r>
-              <a:t>• WebRTC API (Audio streams)</a:t>
+              <a:t>• Web Speech API (TTS Vocalizer)</a:t>
             </a:r>
           </a:p>
         </p:txBody>
@@ -5722,7 +5722,7 @@
               </a:defRPr>
             </a:pPr>
             <a:r>
-              <a:t>BACKEND (NODE &amp; AI)</a:t>
+              <a:t>BACKEND &amp; AI</a:t>
             </a:r>
           </a:p>
           <a:p>
@@ -5738,7 +5738,7 @@
               </a:defRPr>
             </a:pPr>
             <a:r>
-              <a:t>Powering express services and LLM orchestration.</a:t>
+              <a:t>Express middleware and Gemini LLM integrations.</a:t>
             </a:r>
           </a:p>
           <a:p>
@@ -5770,7 +5770,7 @@
               </a:defRPr>
             </a:pPr>
             <a:r>
-              <a:t>• LangChain.js / LlamaIndex</a:t>
+              <a:t>• Google Gemini 2.5 Flash SDK</a:t>
             </a:r>
           </a:p>
           <a:p>
@@ -5786,7 +5786,7 @@
               </a:defRPr>
             </a:pPr>
             <a:r>
-              <a:t>• Gemini Pro &amp; OpenAI API</a:t>
+              <a:t>• Multer File Ingestor</a:t>
             </a:r>
           </a:p>
           <a:p>
@@ -5802,7 +5802,7 @@
               </a:defRPr>
             </a:pPr>
             <a:r>
-              <a:t>• Deepgram / Whisper API</a:t>
+              <a:t>• Dynamic Quiz Generator</a:t>
             </a:r>
           </a:p>
           <a:p>
@@ -5818,7 +5818,7 @@
               </a:defRPr>
             </a:pPr>
             <a:r>
-              <a:t>• Socket.io (Real-time updates)</a:t>
+              <a:t>• Dynamic Translation endpoints</a:t>
             </a:r>
           </a:p>
         </p:txBody>
@@ -5902,7 +5902,7 @@
               </a:defRPr>
             </a:pPr>
             <a:r>
-              <a:t>DATABASE &amp; CLOUD</a:t>
+              <a:t>UTILITIES &amp; DEPLOY</a:t>
             </a:r>
           </a:p>
           <a:p>
@@ -5918,7 +5918,7 @@
               </a:defRPr>
             </a:pPr>
             <a:r>
-              <a:t>Ensuring data persistence and fast edge-deploys.</a:t>
+              <a:t>Staging, documentation, and cloud execution.</a:t>
             </a:r>
           </a:p>
           <a:p>
@@ -5934,7 +5934,7 @@
               </a:defRPr>
             </a:pPr>
             <a:r>
-              <a:t>• MongoDB Atlas (NoSQL database)</a:t>
+              <a:t>• reportlab (PDF Compiler)</a:t>
             </a:r>
           </a:p>
           <a:p>
@@ -5950,7 +5950,7 @@
               </a:defRPr>
             </a:pPr>
             <a:r>
-              <a:t>• Redis Cache (Session management)</a:t>
+              <a:t>• python-pptx (Deck Generator)</a:t>
             </a:r>
           </a:p>
           <a:p>
@@ -5966,7 +5966,7 @@
               </a:defRPr>
             </a:pPr>
             <a:r>
-              <a:t>• AWS S3 (Lecture audio storage)</a:t>
+              <a:t>• Git &amp; GitHub Version Control</a:t>
             </a:r>
           </a:p>
           <a:p>
@@ -5982,7 +5982,7 @@
               </a:defRPr>
             </a:pPr>
             <a:r>
-              <a:t>• Render / AWS EC2</a:t>
+              <a:t>• Render Cloud Web Services</a:t>
             </a:r>
           </a:p>
           <a:p>
@@ -5998,7 +5998,7 @@
               </a:defRPr>
             </a:pPr>
             <a:r>
-              <a:t>• Docker Containerization</a:t>
+              <a:t>• Unified MERN static delivery</a:t>
             </a:r>
           </a:p>
         </p:txBody>

</xml_diff>

<commit_message>
Create fresh presentation slides from scratch according to final completed prototype
</commit_message>
<xml_diff>
--- a/AcademixIQ_Pitch_Deck.pptx
+++ b/AcademixIQ_Pitch_Deck.pptx
@@ -3194,7 +3194,7 @@
         <p:spPr>
           <a:xfrm>
             <a:off x="914400" y="1645920"/>
-            <a:ext cx="10332720" cy="2286000"/>
+            <a:ext cx="10332720" cy="2926080"/>
           </a:xfrm>
           <a:prstGeom prst="rect">
             <a:avLst/>
@@ -3209,7 +3209,7 @@
           <a:p>
             <a:pPr>
               <a:spcAft>
-                <a:spcPts val="1000"/>
+                <a:spcPts val="800"/>
               </a:spcAft>
               <a:defRPr sz="6400" b="1">
                 <a:solidFill>
@@ -3225,9 +3225,9 @@
           <a:p>
             <a:pPr>
               <a:spcAft>
-                <a:spcPts val="2000"/>
+                <a:spcPts val="1200"/>
               </a:spcAft>
-              <a:defRPr sz="2200">
+              <a:defRPr sz="2400" b="1">
                 <a:solidFill>
                   <a:srgbClr val="10B981"/>
                 </a:solidFill>
@@ -3235,7 +3235,7 @@
               </a:defRPr>
             </a:pPr>
             <a:r>
-              <a:t>AI-Powered Smart Learning Companion &amp; Accessibility Hub</a:t>
+              <a:t>Multi-Modal AI Classroom Accessibility Platform</a:t>
             </a:r>
           </a:p>
           <a:p>
@@ -3248,7 +3248,7 @@
               </a:defRPr>
             </a:pPr>
             <a:r>
-              <a:t>Bharat Academix CodeQuest 2026  |  Round 1: Idea Proposal</a:t>
+              <a:t>Democratizing Academic Content through Adaptive Visualizations, Regional Translations, &amp; Mastery Diagnostic Tools</a:t>
             </a:r>
           </a:p>
         </p:txBody>
@@ -3262,7 +3262,7 @@
         <p:spPr>
           <a:xfrm>
             <a:off x="914400" y="4754880"/>
-            <a:ext cx="5486400" cy="1371600"/>
+            <a:ext cx="5943600" cy="1371600"/>
           </a:xfrm>
           <a:prstGeom prst="rect">
             <a:avLst/>
@@ -3284,7 +3284,7 @@
               </a:defRPr>
             </a:pPr>
             <a:r>
-              <a:t>Team: ayushkhaitan2004</a:t>
+              <a:t>Team ID: ayushkhaitan2004</a:t>
             </a:r>
           </a:p>
           <a:p>
@@ -3310,7 +3310,7 @@
               </a:defRPr>
             </a:pPr>
             <a:r>
-              <a:t>Themes: EdTech, AI/ML, Accessibility &amp; Inclusion</a:t>
+              <a:t>Bharat Academix CodeQuest 2026  |  Final Submission</a:t>
             </a:r>
           </a:p>
         </p:txBody>
@@ -3446,7 +3446,7 @@
           <a:lstStyle/>
           <a:p>
             <a:pPr>
-              <a:defRPr sz="3600" b="1">
+              <a:defRPr sz="3200" b="1">
                 <a:solidFill>
                   <a:srgbClr val="0A192F"/>
                 </a:solidFill>
@@ -3454,7 +3454,7 @@
               </a:defRPr>
             </a:pPr>
             <a:r>
-              <a:t>The Problem Statement</a:t>
+              <a:t>The Problem Statement in Indian Classrooms</a:t>
             </a:r>
           </a:p>
         </p:txBody>
@@ -3478,7 +3478,7 @@
           </a:solidFill>
           <a:ln w="19050">
             <a:solidFill>
-              <a:srgbClr val="10B981"/>
+              <a:srgbClr val="0A192F"/>
             </a:solidFill>
           </a:ln>
         </p:spPr>
@@ -3512,8 +3512,8 @@
         </p:nvSpPr>
         <p:spPr>
           <a:xfrm>
-            <a:off x="1005840" y="1554480"/>
-            <a:ext cx="4572000" cy="4389120"/>
+            <a:off x="914400" y="1554480"/>
+            <a:ext cx="4754880" cy="4389120"/>
           </a:xfrm>
           <a:prstGeom prst="rect">
             <a:avLst/>
@@ -3528,7 +3528,7 @@
           <a:p>
             <a:pPr>
               <a:spcAft>
-                <a:spcPts val="1800"/>
+                <a:spcPts val="1600"/>
               </a:spcAft>
               <a:defRPr sz="2000" b="1">
                 <a:solidFill>
@@ -3538,7 +3538,7 @@
               </a:defRPr>
             </a:pPr>
             <a:r>
-              <a:t>Key Challenges in Indian Education:</a:t>
+              <a:t>Core Accessibility Barriers:</a:t>
             </a:r>
           </a:p>
           <a:p>
@@ -3553,7 +3553,7 @@
                   <a:srgbClr val="0A192F"/>
                 </a:solidFill>
               </a:rPr>
-              <a:t>• Passive Learning Model:</a:t>
+              <a:t>• Linguistic Exclusion: </a:t>
             </a:r>
             <a:r>
               <a:rPr sz="1300">
@@ -3561,7 +3561,7 @@
                   <a:srgbClr val="1E293B"/>
                 </a:solidFill>
               </a:rPr>
-              <a:t> Traditional systems rely on one-way lectures, leading to poor retention and zero real-time personalized feedback.</a:t>
+              <a:t> Over 80% of digital academic literature is in English. Vernacular medium students fall behind due to language comprehension gaps.</a:t>
             </a:r>
           </a:p>
           <a:p>
@@ -3576,7 +3576,7 @@
                   <a:srgbClr val="0A192F"/>
                 </a:solidFill>
               </a:rPr>
-              <a:t>• Regional Language Barriers:</a:t>
+              <a:t>• Cognitive Strain: </a:t>
             </a:r>
             <a:r>
               <a:rPr sz="1300">
@@ -3584,7 +3584,7 @@
                   <a:srgbClr val="1E293B"/>
                 </a:solidFill>
               </a:rPr>
-              <a:t> 80%+ of higher academic research, papers, and specialized resources are exclusively in English, isolating regional-medium students.</a:t>
+              <a:t> Students with learning profiles like ADHD or Dyslexia face severe text fatigue when presented with long, unstructured slides or textbook chapters.</a:t>
             </a:r>
           </a:p>
           <a:p>
@@ -3599,7 +3599,7 @@
                   <a:srgbClr val="0A192F"/>
                 </a:solidFill>
               </a:rPr>
-              <a:t>• Accessibility Gaps:</a:t>
+              <a:t>• Diagnostic Mastery Gaps: </a:t>
             </a:r>
             <a:r>
               <a:rPr sz="1300">
@@ -3607,7 +3607,7 @@
                   <a:srgbClr val="1E293B"/>
                 </a:solidFill>
               </a:rPr>
-              <a:t> Neurodivergent learners (ADHD, Dyslexia) and visually/hearing-impaired students lack interactive, adaptive support in physical/digital classrooms.</a:t>
+              <a:t> Standard classrooms evaluate retrospectively. There is no real-time diagnostic pipeline to map exactly which subconcept a student struggles to master.</a:t>
             </a:r>
           </a:p>
         </p:txBody>
@@ -3665,8 +3665,8 @@
         </p:nvSpPr>
         <p:spPr>
           <a:xfrm>
-            <a:off x="6492240" y="1554480"/>
-            <a:ext cx="4572000" cy="4389120"/>
+            <a:off x="6400800" y="1554480"/>
+            <a:ext cx="4754880" cy="4389120"/>
           </a:xfrm>
           <a:prstGeom prst="rect">
             <a:avLst/>
@@ -3681,7 +3681,7 @@
           <a:p>
             <a:pPr>
               <a:spcAft>
-                <a:spcPts val="2400"/>
+                <a:spcPts val="2000"/>
               </a:spcAft>
               <a:defRPr sz="2000" b="1">
                 <a:solidFill>
@@ -3691,7 +3691,7 @@
               </a:defRPr>
             </a:pPr>
             <a:r>
-              <a:t>The Opportunity in Numbers:</a:t>
+              <a:t>The Scale of Impact:</a:t>
             </a:r>
           </a:p>
           <a:p>
@@ -3701,12 +3701,12 @@
               </a:spcAft>
             </a:pPr>
             <a:r>
-              <a:rPr b="1" sz="2400">
+              <a:rPr b="1" sz="2200">
                 <a:solidFill>
                   <a:srgbClr val="FFFFFF"/>
                 </a:solidFill>
               </a:rPr>
-              <a:t>250 Million+
+              <a:t>10M+ Students
 </a:t>
             </a:r>
             <a:r>
@@ -3715,7 +3715,7 @@
                   <a:srgbClr val="10B981"/>
                 </a:solidFill>
               </a:rPr>
-              <a:t>Students enrolled in Indian primary/secondary schools needing tailored education.</a:t>
+              <a:t>Studying in regional language mediums face technical language gaps annually.</a:t>
             </a:r>
           </a:p>
           <a:p>
@@ -3725,12 +3725,12 @@
               </a:spcAft>
             </a:pPr>
             <a:r>
-              <a:rPr b="1" sz="2400">
+              <a:rPr b="1" sz="2200">
                 <a:solidFill>
                   <a:srgbClr val="FFFFFF"/>
                 </a:solidFill>
               </a:rPr>
-              <a:t>&lt; 5%
+              <a:t>&lt; 5% of EdTech
 </a:t>
             </a:r>
             <a:r>
@@ -3739,7 +3739,7 @@
                   <a:srgbClr val="10B981"/>
                 </a:solidFill>
               </a:rPr>
-              <a:t>Of educational content conforms to international accessibility standards in regional domains.</a:t>
+              <a:t>Provides customizable typographic or visual focus tools for neurodiverse students.</a:t>
             </a:r>
           </a:p>
           <a:p>
@@ -3749,12 +3749,12 @@
               </a:spcAft>
             </a:pPr>
             <a:r>
-              <a:rPr b="1" sz="2400">
+              <a:rPr b="1" sz="2200">
                 <a:solidFill>
                   <a:srgbClr val="FFFFFF"/>
                 </a:solidFill>
               </a:rPr>
-              <a:t>80%
+              <a:t>48 Hours
 </a:t>
             </a:r>
             <a:r>
@@ -3763,7 +3763,7 @@
                   <a:srgbClr val="10B981"/>
                 </a:solidFill>
               </a:rPr>
-              <a:t>Of classroom knowledge loss occurs within 48 hours without active reinforcement.</a:t>
+              <a:t>Is the typical timeline where a student forgets 80% of unstructured text-based lessons.</a:t>
             </a:r>
           </a:p>
         </p:txBody>
@@ -3899,7 +3899,7 @@
           <a:lstStyle/>
           <a:p>
             <a:pPr>
-              <a:defRPr sz="3600" b="1">
+              <a:defRPr sz="3200" b="1">
                 <a:solidFill>
                   <a:srgbClr val="0A192F"/>
                 </a:solidFill>
@@ -3907,49 +3907,14 @@
               </a:defRPr>
             </a:pPr>
             <a:r>
-              <a:t>The Proposed Solution - AcademixIQ</a:t>
-            </a:r>
-          </a:p>
-        </p:txBody>
-      </p:sp>
-      <p:sp>
-        <p:nvSpPr>
-          <p:cNvPr id="5" name="TextBox 4"/>
-          <p:cNvSpPr txBox="1"/>
-          <p:nvPr/>
-        </p:nvSpPr>
-        <p:spPr>
-          <a:xfrm>
-            <a:off x="731520" y="6035040"/>
-            <a:ext cx="10698480" cy="457200"/>
-          </a:xfrm>
-          <a:prstGeom prst="rect">
-            <a:avLst/>
-          </a:prstGeom>
-          <a:noFill/>
-        </p:spPr>
-        <p:txBody>
-          <a:bodyPr wrap="square">
-            <a:spAutoFit/>
-          </a:bodyPr>
-          <a:lstStyle/>
-          <a:p>
-            <a:pPr algn="ctr">
-              <a:defRPr b="1" sz="1100">
-                <a:solidFill>
-                  <a:srgbClr val="059669"/>
-                </a:solidFill>
-              </a:defRPr>
-            </a:pPr>
-            <a:r>
-              <a:t>Direct Alignment: Education Technology  |  Social Impact &amp; Accessibility  |  AI &amp; Machine Learning</a:t>
-            </a:r>
-          </a:p>
-        </p:txBody>
-      </p:sp>
-      <p:sp>
-        <p:nvSpPr>
-          <p:cNvPr id="6" name="Rounded Rectangle 5"/>
+              <a:t>AcademixIQ: The Four Multi-Modal Pillars</a:t>
+            </a:r>
+          </a:p>
+        </p:txBody>
+      </p:sp>
+      <p:sp>
+        <p:nvSpPr>
+          <p:cNvPr id="5" name="Rounded Rectangle 4"/>
           <p:cNvSpPr/>
           <p:nvPr/>
         </p:nvSpPr>
@@ -3994,7 +3959,7 @@
       </p:sp>
       <p:sp>
         <p:nvSpPr>
-          <p:cNvPr id="7" name="TextBox 6"/>
+          <p:cNvPr id="6" name="TextBox 5"/>
           <p:cNvSpPr txBox="1"/>
           <p:nvPr/>
         </p:nvSpPr>
@@ -4026,7 +3991,7 @@
               </a:defRPr>
             </a:pPr>
             <a:r>
-              <a:t>BhashaTranslate</a:t>
+              <a:t>VisualMind Canvas</a:t>
             </a:r>
           </a:p>
           <a:p>
@@ -4039,14 +4004,14 @@
               </a:defRPr>
             </a:pPr>
             <a:r>
-              <a:t>Real-time vernacular lecture transcription, translating English classes to local Indian languages (Hindi, Tamil, etc.) instantly.</a:t>
-            </a:r>
-          </a:p>
-        </p:txBody>
-      </p:sp>
-      <p:sp>
-        <p:nvSpPr>
-          <p:cNvPr id="8" name="Rounded Rectangle 7"/>
+              <a:t>Transforms complex technical documents or text notes into interactive, 3D conceptual mind maps. Features dynamic node expansion powered by Gemini 2.5 Flash.</a:t>
+            </a:r>
+          </a:p>
+        </p:txBody>
+      </p:sp>
+      <p:sp>
+        <p:nvSpPr>
+          <p:cNvPr id="7" name="Rounded Rectangle 6"/>
           <p:cNvSpPr/>
           <p:nvPr/>
         </p:nvSpPr>
@@ -4091,7 +4056,7 @@
       </p:sp>
       <p:sp>
         <p:nvSpPr>
-          <p:cNvPr id="9" name="TextBox 8"/>
+          <p:cNvPr id="8" name="TextBox 7"/>
           <p:cNvSpPr txBox="1"/>
           <p:nvPr/>
         </p:nvSpPr>
@@ -4123,7 +4088,7 @@
               </a:defRPr>
             </a:pPr>
             <a:r>
-              <a:t>VisualMind Canvas</a:t>
+              <a:t>BhashaTranslate Live</a:t>
             </a:r>
           </a:p>
           <a:p>
@@ -4136,14 +4101,14 @@
               </a:defRPr>
             </a:pPr>
             <a:r>
-              <a:t>Generates real-time, interactive mind maps and visual flowcharts from lecture audio or PDFs to simplify complex concepts.</a:t>
-            </a:r>
-          </a:p>
-        </p:txBody>
-      </p:sp>
-      <p:sp>
-        <p:nvSpPr>
-          <p:cNvPr id="10" name="Rounded Rectangle 9"/>
+              <a:t>Captures classroom voice audio via browser microphone. Translates English lessons into 6 major regional Indian scripts (Hindi, Tamil, etc.) with synchronized TTS.</a:t>
+            </a:r>
+          </a:p>
+        </p:txBody>
+      </p:sp>
+      <p:sp>
+        <p:nvSpPr>
+          <p:cNvPr id="9" name="Rounded Rectangle 8"/>
           <p:cNvSpPr/>
           <p:nvPr/>
         </p:nvSpPr>
@@ -4188,7 +4153,7 @@
       </p:sp>
       <p:sp>
         <p:nvSpPr>
-          <p:cNvPr id="11" name="TextBox 10"/>
+          <p:cNvPr id="10" name="TextBox 9"/>
           <p:cNvSpPr txBox="1"/>
           <p:nvPr/>
         </p:nvSpPr>
@@ -4220,7 +4185,7 @@
               </a:defRPr>
             </a:pPr>
             <a:r>
-              <a:t>SkillBridge AI</a:t>
+              <a:t>SkillBridge Evaluation</a:t>
             </a:r>
           </a:p>
           <a:p>
@@ -4233,14 +4198,14 @@
               </a:defRPr>
             </a:pPr>
             <a:r>
-              <a:t>Contextual, adaptive quiz generation that analyzes user performance to pinpoint concept gaps and customize roadmaps.</a:t>
-            </a:r>
-          </a:p>
-        </p:txBody>
-      </p:sp>
-      <p:sp>
-        <p:nvSpPr>
-          <p:cNvPr id="12" name="Rounded Rectangle 11"/>
+              <a:t>Contextual MCQ assessments mapped directly onto concept nodes. Identifies gaps, updates node colors (Mastered/Gap), and compiles customized study checklists.</a:t>
+            </a:r>
+          </a:p>
+        </p:txBody>
+      </p:sp>
+      <p:sp>
+        <p:nvSpPr>
+          <p:cNvPr id="11" name="Rounded Rectangle 10"/>
           <p:cNvSpPr/>
           <p:nvPr/>
         </p:nvSpPr>
@@ -4285,7 +4250,7 @@
       </p:sp>
       <p:sp>
         <p:nvSpPr>
-          <p:cNvPr id="13" name="TextBox 12"/>
+          <p:cNvPr id="12" name="TextBox 11"/>
           <p:cNvSpPr txBox="1"/>
           <p:nvPr/>
         </p:nvSpPr>
@@ -4330,7 +4295,7 @@
               </a:defRPr>
             </a:pPr>
             <a:r>
-              <a:t>High-contrast screen-reader styles, speech-to-text navigation, and simplified content modules for neurodiverse learners.</a:t>
+              <a:t>Accessibility settings offering OpenDyslexic fonts, mouse-guided focus rulers for ADHD, SVG colorblindness filters, and hands-free voice command navigation.</a:t>
             </a:r>
           </a:p>
         </p:txBody>
@@ -4368,11 +4333,11 @@
             <a:avLst/>
           </a:prstGeom>
           <a:solidFill>
-            <a:srgbClr val="0A192F"/>
+            <a:srgbClr val="F8FAFC"/>
           </a:solidFill>
           <a:ln>
             <a:solidFill>
-              <a:srgbClr val="0A192F"/>
+              <a:srgbClr val="F8FAFC"/>
             </a:solidFill>
           </a:ln>
         </p:spPr>
@@ -4466,29 +4431,74 @@
           <a:lstStyle/>
           <a:p>
             <a:pPr>
-              <a:defRPr sz="3600" b="1">
-                <a:solidFill>
-                  <a:srgbClr val="FFFFFF"/>
+              <a:defRPr sz="3200" b="1">
+                <a:solidFill>
+                  <a:srgbClr val="0A192F"/>
                 </a:solidFill>
                 <a:latin typeface="Arial"/>
               </a:defRPr>
             </a:pPr>
             <a:r>
-              <a:t>Interactive Student Dashboard Mockup</a:t>
-            </a:r>
-          </a:p>
-        </p:txBody>
-      </p:sp>
-      <p:sp>
-        <p:nvSpPr>
-          <p:cNvPr id="5" name="TextBox 4"/>
+              <a:t>VisualMind: Interactive Concept Mapping</a:t>
+            </a:r>
+          </a:p>
+        </p:txBody>
+      </p:sp>
+      <p:sp>
+        <p:nvSpPr>
+          <p:cNvPr id="5" name="Rounded Rectangle 4"/>
+          <p:cNvSpPr/>
+          <p:nvPr/>
+        </p:nvSpPr>
+        <p:spPr>
+          <a:xfrm>
+            <a:off x="731520" y="1371600"/>
+            <a:ext cx="4572000" cy="4754880"/>
+          </a:xfrm>
+          <a:prstGeom prst="roundRect">
+            <a:avLst/>
+          </a:prstGeom>
+          <a:solidFill>
+            <a:srgbClr val="FFFFFF"/>
+          </a:solidFill>
+          <a:ln w="19050">
+            <a:solidFill>
+              <a:srgbClr val="0A192F"/>
+            </a:solidFill>
+          </a:ln>
+        </p:spPr>
+        <p:style>
+          <a:lnRef idx="1">
+            <a:schemeClr val="accent1"/>
+          </a:lnRef>
+          <a:fillRef idx="3">
+            <a:schemeClr val="accent1"/>
+          </a:fillRef>
+          <a:effectRef idx="2">
+            <a:schemeClr val="accent1"/>
+          </a:effectRef>
+          <a:fontRef idx="minor">
+            <a:schemeClr val="lt1"/>
+          </a:fontRef>
+        </p:style>
+        <p:txBody>
+          <a:bodyPr rtlCol="0" anchor="ctr"/>
+          <a:lstStyle/>
+          <a:p>
+            <a:pPr algn="ctr"/>
+          </a:p>
+        </p:txBody>
+      </p:sp>
+      <p:sp>
+        <p:nvSpPr>
+          <p:cNvPr id="6" name="TextBox 5"/>
           <p:cNvSpPr txBox="1"/>
           <p:nvPr/>
         </p:nvSpPr>
         <p:spPr>
           <a:xfrm>
-            <a:off x="731520" y="1463040"/>
-            <a:ext cx="4389120" cy="4572000"/>
+            <a:off x="914400" y="1554480"/>
+            <a:ext cx="4206240" cy="4389120"/>
           </a:xfrm>
           <a:prstGeom prst="rect">
             <a:avLst/>
@@ -4503,17 +4513,17 @@
           <a:p>
             <a:pPr>
               <a:spcAft>
-                <a:spcPts val="1600"/>
+                <a:spcPts val="1500"/>
               </a:spcAft>
-              <a:defRPr sz="2200" b="1">
-                <a:solidFill>
-                  <a:srgbClr val="10B981"/>
+              <a:defRPr sz="2000" b="1">
+                <a:solidFill>
+                  <a:srgbClr val="0A192F"/>
                 </a:solidFill>
                 <a:latin typeface="Arial"/>
               </a:defRPr>
             </a:pPr>
             <a:r>
-              <a:t>AcademixIQ Student Dashboard:</a:t>
+              <a:t>Conceptual Graph Modeling:</a:t>
             </a:r>
           </a:p>
           <a:p>
@@ -4523,20 +4533,20 @@
               </a:spcAft>
             </a:pPr>
             <a:r>
-              <a:rPr b="1" sz="1400">
-                <a:solidFill>
-                  <a:srgbClr val="FFFFFF"/>
+              <a:rPr b="1" sz="1300">
+                <a:solidFill>
+                  <a:srgbClr val="0A192F"/>
                 </a:solidFill>
               </a:rPr>
-              <a:t>• Glassmorphism UI:</a:t>
+              <a:t>• Structured Graphing: </a:t>
             </a:r>
             <a:r>
               <a:rPr sz="1300">
                 <a:solidFill>
-                  <a:srgbClr val="10B981"/>
+                  <a:srgbClr val="1E293B"/>
                 </a:solidFill>
               </a:rPr>
-              <a:t> Optimized for focus with a modern dark aesthetics design system.</a:t>
+              <a:t> Breaks arbitrary academic topics into Root, Subtopic, and Detail nodes on an interactive HTML5 canvas.</a:t>
             </a:r>
           </a:p>
           <a:p>
@@ -4546,20 +4556,20 @@
               </a:spcAft>
             </a:pPr>
             <a:r>
-              <a:rPr b="1" sz="1400">
-                <a:solidFill>
-                  <a:srgbClr val="FFFFFF"/>
+              <a:rPr b="1" sz="1300">
+                <a:solidFill>
+                  <a:srgbClr val="0A192F"/>
                 </a:solidFill>
               </a:rPr>
-              <a:t>• Visual Mind-Mapping:</a:t>
+              <a:t>• Self-Paced Navigation: </a:t>
             </a:r>
             <a:r>
               <a:rPr sz="1300">
                 <a:solidFill>
-                  <a:srgbClr val="10B981"/>
+                  <a:srgbClr val="1E293B"/>
                 </a:solidFill>
               </a:rPr>
-              <a:t> Center stage is occupied by interactive node diagrams illustrating the relation between academic topics.</a:t>
+              <a:t> Selecting a node displays summaries, flashcards, and conceptual study questions inside a sliding drawer panel.</a:t>
             </a:r>
           </a:p>
           <a:p>
@@ -4569,27 +4579,27 @@
               </a:spcAft>
             </a:pPr>
             <a:r>
-              <a:rPr b="1" sz="1400">
-                <a:solidFill>
-                  <a:srgbClr val="FFFFFF"/>
+              <a:rPr b="1" sz="1300">
+                <a:solidFill>
+                  <a:srgbClr val="0A192F"/>
                 </a:solidFill>
               </a:rPr>
-              <a:t>• Real-Time Transcripts:</a:t>
+              <a:t>• Dynamic Node Expansion: </a:t>
             </a:r>
             <a:r>
               <a:rPr sz="1300">
                 <a:solidFill>
-                  <a:srgbClr val="10B981"/>
+                  <a:srgbClr val="1E293B"/>
                 </a:solidFill>
               </a:rPr>
-              <a:t> Left/right panels stream live translations, enabling students to switch languages dynamically.</a:t>
+              <a:t> Students double-click subtopics to prompt Gemini to generate and branch out further detail nodes on the fly.</a:t>
             </a:r>
           </a:p>
         </p:txBody>
       </p:sp>
       <p:pic>
         <p:nvPicPr>
-          <p:cNvPr id="6" name="Picture 5" descr="mockup_dashboard.png"/>
+          <p:cNvPr id="7" name="Picture 6" descr="mockup_dashboard.png"/>
           <p:cNvPicPr>
             <a:picLocks noChangeAspect="1"/>
           </p:cNvPicPr>
@@ -4603,8 +4613,8 @@
         </p:blipFill>
         <p:spPr>
           <a:xfrm>
-            <a:off x="5486400" y="1463040"/>
-            <a:ext cx="5943600" cy="4434840"/>
+            <a:off x="5577840" y="1371600"/>
+            <a:ext cx="5852160" cy="4754880"/>
           </a:xfrm>
           <a:prstGeom prst="rect">
             <a:avLst/>
@@ -4742,7 +4752,7 @@
           <a:lstStyle/>
           <a:p>
             <a:pPr>
-              <a:defRPr sz="3600" b="1">
+              <a:defRPr sz="3200" b="1">
                 <a:solidFill>
                   <a:srgbClr val="0A192F"/>
                 </a:solidFill>
@@ -4750,7 +4760,7 @@
               </a:defRPr>
             </a:pPr>
             <a:r>
-              <a:t>System Architecture &amp; Processing Pipeline</a:t>
+              <a:t>BhashaTranslate: Regional Language Hub</a:t>
             </a:r>
           </a:p>
         </p:txBody>
@@ -4763,8 +4773,8 @@
         </p:nvSpPr>
         <p:spPr>
           <a:xfrm>
-            <a:off x="731520" y="1645920"/>
-            <a:ext cx="2926080" cy="4114800"/>
+            <a:off x="731520" y="1371600"/>
+            <a:ext cx="5120640" cy="4754880"/>
           </a:xfrm>
           <a:prstGeom prst="roundRect">
             <a:avLst/>
@@ -4774,7 +4784,7 @@
           </a:solidFill>
           <a:ln w="19050">
             <a:solidFill>
-              <a:srgbClr val="0A192F"/>
+              <a:srgbClr val="10B981"/>
             </a:solidFill>
           </a:ln>
         </p:spPr>
@@ -4808,8 +4818,8 @@
         </p:nvSpPr>
         <p:spPr>
           <a:xfrm>
-            <a:off x="914400" y="1828800"/>
-            <a:ext cx="2560320" cy="3749039"/>
+            <a:off x="914400" y="1554480"/>
+            <a:ext cx="4754880" cy="4389120"/>
           </a:xfrm>
           <a:prstGeom prst="rect">
             <a:avLst/>
@@ -4826,148 +4836,98 @@
               <a:spcAft>
                 <a:spcPts val="1500"/>
               </a:spcAft>
-              <a:defRPr b="1" sz="1600">
+              <a:defRPr sz="2000" b="1">
                 <a:solidFill>
                   <a:srgbClr val="0A192F"/>
                 </a:solidFill>
+                <a:latin typeface="Arial"/>
               </a:defRPr>
             </a:pPr>
             <a:r>
-              <a:t>1. INGESTION LAYER</a:t>
+              <a:t>Classroom Audio Translation:</a:t>
             </a:r>
           </a:p>
           <a:p>
             <a:pPr>
               <a:spcAft>
-                <a:spcPts val="1000"/>
+                <a:spcPts val="1200"/>
               </a:spcAft>
-              <a:defRPr sz="1300">
+            </a:pPr>
+            <a:r>
+              <a:rPr b="1" sz="1300">
+                <a:solidFill>
+                  <a:srgbClr val="0A192F"/>
+                </a:solidFill>
+              </a:rPr>
+              <a:t>• Live Vernacular Script Output: </a:t>
+            </a:r>
+            <a:r>
+              <a:rPr sz="1300">
                 <a:solidFill>
                   <a:srgbClr val="1E293B"/>
                 </a:solidFill>
-              </a:defRPr>
-            </a:pPr>
-            <a:r>
-              <a:t>• Live Classroom Audio Feed</a:t>
+              </a:rPr>
+              <a:t> Captures English lecture audio and instantly translates it into standard regional scripts (Devanagari, Tamil, etc.), rather than phonetic English letters.</a:t>
             </a:r>
           </a:p>
           <a:p>
             <a:pPr>
               <a:spcAft>
-                <a:spcPts val="1000"/>
+                <a:spcPts val="1200"/>
               </a:spcAft>
-              <a:defRPr sz="1300">
+            </a:pPr>
+            <a:r>
+              <a:rPr b="1" sz="1300">
+                <a:solidFill>
+                  <a:srgbClr val="0A192F"/>
+                </a:solidFill>
+              </a:rPr>
+              <a:t>• SpeechSynthesis (TTS) Vocalizer: </a:t>
+            </a:r>
+            <a:r>
+              <a:rPr sz="1300">
                 <a:solidFill>
                   <a:srgbClr val="1E293B"/>
                 </a:solidFill>
-              </a:defRPr>
-            </a:pPr>
-            <a:r>
-              <a:t>• PDFs &amp; Textbook Scans</a:t>
+              </a:rPr>
+              <a:t> Integrates system regional voices (Hindi, Tamil, Kannada, Telugu, Bengali, Marathi) to speak translations aloud with local accent profiles.</a:t>
             </a:r>
           </a:p>
           <a:p>
             <a:pPr>
               <a:spcAft>
-                <a:spcPts val="1000"/>
+                <a:spcPts val="1200"/>
               </a:spcAft>
-              <a:defRPr sz="1300">
+            </a:pPr>
+            <a:r>
+              <a:rPr b="1" sz="1300">
+                <a:solidFill>
+                  <a:srgbClr val="0A192F"/>
+                </a:solidFill>
+              </a:rPr>
+              <a:t>• Asynchronous Voice Loading: </a:t>
+            </a:r>
+            <a:r>
+              <a:rPr sz="1300">
                 <a:solidFill>
                   <a:srgbClr val="1E293B"/>
                 </a:solidFill>
-              </a:defRPr>
-            </a:pPr>
-            <a:r>
-              <a:t>• Youtube Lecture URLs</a:t>
-            </a:r>
-          </a:p>
-          <a:p>
-            <a:pPr>
-              <a:spcAft>
-                <a:spcPts val="1000"/>
-              </a:spcAft>
-              <a:defRPr sz="1300">
-                <a:solidFill>
-                  <a:srgbClr val="1E293B"/>
-                </a:solidFill>
-              </a:defRPr>
-            </a:pPr>
-            <a:r>
-              <a:t>• WebRTC Voice Commands</a:t>
-            </a:r>
-          </a:p>
-          <a:p>
-            <a:pPr>
-              <a:spcAft>
-                <a:spcPts val="1000"/>
-              </a:spcAft>
-              <a:defRPr sz="1300">
-                <a:solidFill>
-                  <a:srgbClr val="1E293B"/>
-                </a:solidFill>
-              </a:defRPr>
-            </a:pPr>
-            <a:r>
-              <a:t>• Peer Tutors Inputs</a:t>
-            </a:r>
-          </a:p>
-        </p:txBody>
-      </p:sp>
-      <p:sp>
-        <p:nvSpPr>
-          <p:cNvPr id="7" name="Right Arrow 6"/>
+              </a:rPr>
+              <a:t> Subscribes to browser voice-change triggers to prevent silent audio execution on page startup.</a:t>
+            </a:r>
+          </a:p>
+        </p:txBody>
+      </p:sp>
+      <p:sp>
+        <p:nvSpPr>
+          <p:cNvPr id="7" name="Rounded Rectangle 6"/>
           <p:cNvSpPr/>
           <p:nvPr/>
         </p:nvSpPr>
         <p:spPr>
           <a:xfrm>
-            <a:off x="3840480" y="3474720"/>
-            <a:ext cx="640080" cy="365760"/>
-          </a:xfrm>
-          <a:prstGeom prst="rightArrow">
-            <a:avLst/>
-          </a:prstGeom>
-          <a:solidFill>
-            <a:srgbClr val="10B981"/>
-          </a:solidFill>
-          <a:ln>
-            <a:solidFill>
-              <a:srgbClr val="10B981"/>
-            </a:solidFill>
-          </a:ln>
-        </p:spPr>
-        <p:style>
-          <a:lnRef idx="1">
-            <a:schemeClr val="accent1"/>
-          </a:lnRef>
-          <a:fillRef idx="3">
-            <a:schemeClr val="accent1"/>
-          </a:fillRef>
-          <a:effectRef idx="2">
-            <a:schemeClr val="accent1"/>
-          </a:effectRef>
-          <a:fontRef idx="minor">
-            <a:schemeClr val="lt1"/>
-          </a:fontRef>
-        </p:style>
-        <p:txBody>
-          <a:bodyPr rtlCol="0" anchor="ctr"/>
-          <a:lstStyle/>
-          <a:p>
-            <a:pPr algn="ctr"/>
-          </a:p>
-        </p:txBody>
-      </p:sp>
-      <p:sp>
-        <p:nvSpPr>
-          <p:cNvPr id="8" name="Rounded Rectangle 7"/>
-          <p:cNvSpPr/>
-          <p:nvPr/>
-        </p:nvSpPr>
-        <p:spPr>
-          <a:xfrm>
-            <a:off x="4663440" y="1645920"/>
-            <a:ext cx="2926080" cy="4114800"/>
+            <a:off x="6217920" y="1371600"/>
+            <a:ext cx="5120640" cy="4754880"/>
           </a:xfrm>
           <a:prstGeom prst="roundRect">
             <a:avLst/>
@@ -5005,14 +4965,14 @@
       </p:sp>
       <p:sp>
         <p:nvSpPr>
-          <p:cNvPr id="9" name="TextBox 8"/>
+          <p:cNvPr id="8" name="TextBox 7"/>
           <p:cNvSpPr txBox="1"/>
           <p:nvPr/>
         </p:nvSpPr>
         <p:spPr>
           <a:xfrm>
-            <a:off x="4846320" y="1828800"/>
-            <a:ext cx="2560320" cy="3749039"/>
+            <a:off x="6400800" y="1554480"/>
+            <a:ext cx="4754880" cy="4389120"/>
           </a:xfrm>
           <a:prstGeom prst="rect">
             <a:avLst/>
@@ -5027,294 +4987,89 @@
           <a:p>
             <a:pPr>
               <a:spcAft>
-                <a:spcPts val="1500"/>
+                <a:spcPts val="2000"/>
               </a:spcAft>
-              <a:defRPr b="1" sz="1600">
+              <a:defRPr sz="2000" b="1">
                 <a:solidFill>
                   <a:srgbClr val="10B981"/>
                 </a:solidFill>
+                <a:latin typeface="Arial"/>
               </a:defRPr>
             </a:pPr>
             <a:r>
-              <a:t>2. CORE AI PIPELINE</a:t>
+              <a:t>High-Fidelity Sandbox Mockups:</a:t>
             </a:r>
           </a:p>
           <a:p>
             <a:pPr>
               <a:spcAft>
-                <a:spcPts val="1000"/>
+                <a:spcPts val="1400"/>
               </a:spcAft>
-              <a:defRPr sz="1300">
+            </a:pPr>
+            <a:r>
+              <a:rPr b="1" sz="1400">
                 <a:solidFill>
                   <a:srgbClr val="FFFFFF"/>
                 </a:solidFill>
-              </a:defRPr>
-            </a:pPr>
-            <a:r>
-              <a:t>• Web Speech API (SpeechRecognition)</a:t>
+              </a:rPr>
+              <a:t>Photosynthesis Lesson Module
+</a:t>
+            </a:r>
+            <a:r>
+              <a:rPr sz="1200">
+                <a:solidFill>
+                  <a:srgbClr val="10B981"/>
+                </a:solidFill>
+              </a:rPr>
+              <a:t>Full 5-page text stream translating scientific processes like Calvin Cycle and RuBisCO into actual Indian scripts.</a:t>
             </a:r>
           </a:p>
           <a:p>
             <a:pPr>
               <a:spcAft>
-                <a:spcPts val="1000"/>
+                <a:spcPts val="1400"/>
               </a:spcAft>
-              <a:defRPr sz="1300">
+            </a:pPr>
+            <a:r>
+              <a:rPr b="1" sz="1400">
                 <a:solidFill>
                   <a:srgbClr val="FFFFFF"/>
                 </a:solidFill>
-              </a:defRPr>
-            </a:pPr>
-            <a:r>
-              <a:t>• Google Gemini 2.5 Flash SDK</a:t>
+              </a:rPr>
+              <a:t>Quantum Computing Module
+</a:t>
+            </a:r>
+            <a:r>
+              <a:rPr sz="1200">
+                <a:solidFill>
+                  <a:srgbClr val="10B981"/>
+                </a:solidFill>
+              </a:rPr>
+              <a:t>Superposition and Shor's Algorithm explanations in native script templates.</a:t>
             </a:r>
           </a:p>
           <a:p>
             <a:pPr>
               <a:spcAft>
-                <a:spcPts val="1000"/>
+                <a:spcPts val="1400"/>
               </a:spcAft>
-              <a:defRPr sz="1300">
+            </a:pPr>
+            <a:r>
+              <a:rPr b="1" sz="1400">
                 <a:solidFill>
                   <a:srgbClr val="FFFFFF"/>
                 </a:solidFill>
-              </a:defRPr>
-            </a:pPr>
-            <a:r>
-              <a:t>• Dynamic Node Expansion logic</a:t>
-            </a:r>
-          </a:p>
-          <a:p>
-            <a:pPr>
-              <a:spcAft>
-                <a:spcPts val="1000"/>
-              </a:spcAft>
-              <a:defRPr sz="1300">
-                <a:solidFill>
-                  <a:srgbClr val="FFFFFF"/>
-                </a:solidFill>
-              </a:defRPr>
-            </a:pPr>
-            <a:r>
-              <a:t>• Web Speech API (SpeechSynthesis TTS)</a:t>
-            </a:r>
-          </a:p>
-          <a:p>
-            <a:pPr>
-              <a:spcAft>
-                <a:spcPts val="1000"/>
-              </a:spcAft>
-              <a:defRPr sz="1300">
-                <a:solidFill>
-                  <a:srgbClr val="FFFFFF"/>
-                </a:solidFill>
-              </a:defRPr>
-            </a:pPr>
-            <a:r>
-              <a:t>• Express Node.js Backend Server</a:t>
-            </a:r>
-          </a:p>
-        </p:txBody>
-      </p:sp>
-      <p:sp>
-        <p:nvSpPr>
-          <p:cNvPr id="10" name="Right Arrow 9"/>
-          <p:cNvSpPr/>
-          <p:nvPr/>
-        </p:nvSpPr>
-        <p:spPr>
-          <a:xfrm>
-            <a:off x="7772400" y="3474720"/>
-            <a:ext cx="640080" cy="365760"/>
-          </a:xfrm>
-          <a:prstGeom prst="rightArrow">
-            <a:avLst/>
-          </a:prstGeom>
-          <a:solidFill>
-            <a:srgbClr val="10B981"/>
-          </a:solidFill>
-          <a:ln>
-            <a:solidFill>
-              <a:srgbClr val="10B981"/>
-            </a:solidFill>
-          </a:ln>
-        </p:spPr>
-        <p:style>
-          <a:lnRef idx="1">
-            <a:schemeClr val="accent1"/>
-          </a:lnRef>
-          <a:fillRef idx="3">
-            <a:schemeClr val="accent1"/>
-          </a:fillRef>
-          <a:effectRef idx="2">
-            <a:schemeClr val="accent1"/>
-          </a:effectRef>
-          <a:fontRef idx="minor">
-            <a:schemeClr val="lt1"/>
-          </a:fontRef>
-        </p:style>
-        <p:txBody>
-          <a:bodyPr rtlCol="0" anchor="ctr"/>
-          <a:lstStyle/>
-          <a:p>
-            <a:pPr algn="ctr"/>
-          </a:p>
-        </p:txBody>
-      </p:sp>
-      <p:sp>
-        <p:nvSpPr>
-          <p:cNvPr id="11" name="Rounded Rectangle 10"/>
-          <p:cNvSpPr/>
-          <p:nvPr/>
-        </p:nvSpPr>
-        <p:spPr>
-          <a:xfrm>
-            <a:off x="8595360" y="1645920"/>
-            <a:ext cx="2834640" cy="4114800"/>
-          </a:xfrm>
-          <a:prstGeom prst="roundRect">
-            <a:avLst/>
-          </a:prstGeom>
-          <a:solidFill>
-            <a:srgbClr val="FFFFFF"/>
-          </a:solidFill>
-          <a:ln w="19050">
-            <a:solidFill>
-              <a:srgbClr val="10B981"/>
-            </a:solidFill>
-          </a:ln>
-        </p:spPr>
-        <p:style>
-          <a:lnRef idx="1">
-            <a:schemeClr val="accent1"/>
-          </a:lnRef>
-          <a:fillRef idx="3">
-            <a:schemeClr val="accent1"/>
-          </a:fillRef>
-          <a:effectRef idx="2">
-            <a:schemeClr val="accent1"/>
-          </a:effectRef>
-          <a:fontRef idx="minor">
-            <a:schemeClr val="lt1"/>
-          </a:fontRef>
-        </p:style>
-        <p:txBody>
-          <a:bodyPr rtlCol="0" anchor="ctr"/>
-          <a:lstStyle/>
-          <a:p>
-            <a:pPr algn="ctr"/>
-          </a:p>
-        </p:txBody>
-      </p:sp>
-      <p:sp>
-        <p:nvSpPr>
-          <p:cNvPr id="12" name="TextBox 11"/>
-          <p:cNvSpPr txBox="1"/>
-          <p:nvPr/>
-        </p:nvSpPr>
-        <p:spPr>
-          <a:xfrm>
-            <a:off x="8778240" y="1828800"/>
-            <a:ext cx="2468880" cy="3749039"/>
-          </a:xfrm>
-          <a:prstGeom prst="rect">
-            <a:avLst/>
-          </a:prstGeom>
-          <a:noFill/>
-        </p:spPr>
-        <p:txBody>
-          <a:bodyPr wrap="square">
-            <a:spAutoFit/>
-          </a:bodyPr>
-          <a:lstStyle/>
-          <a:p>
-            <a:pPr>
-              <a:spcAft>
-                <a:spcPts val="1500"/>
-              </a:spcAft>
-              <a:defRPr b="1" sz="1600">
-                <a:solidFill>
-                  <a:srgbClr val="0A192F"/>
-                </a:solidFill>
-              </a:defRPr>
-            </a:pPr>
-            <a:r>
-              <a:t>3. PRESENTATION LAYER</a:t>
-            </a:r>
-          </a:p>
-          <a:p>
-            <a:pPr>
-              <a:spcAft>
-                <a:spcPts val="1000"/>
-              </a:spcAft>
-              <a:defRPr sz="1300">
-                <a:solidFill>
-                  <a:srgbClr val="1E293B"/>
-                </a:solidFill>
-              </a:defRPr>
-            </a:pPr>
-            <a:r>
-              <a:t>• Interactive Canvas Nodes</a:t>
-            </a:r>
-          </a:p>
-          <a:p>
-            <a:pPr>
-              <a:spcAft>
-                <a:spcPts val="1000"/>
-              </a:spcAft>
-              <a:defRPr sz="1300">
-                <a:solidFill>
-                  <a:srgbClr val="1E293B"/>
-                </a:solidFill>
-              </a:defRPr>
-            </a:pPr>
-            <a:r>
-              <a:t>• Adaptive Study Cards</a:t>
-            </a:r>
-          </a:p>
-          <a:p>
-            <a:pPr>
-              <a:spcAft>
-                <a:spcPts val="1000"/>
-              </a:spcAft>
-              <a:defRPr sz="1300">
-                <a:solidFill>
-                  <a:srgbClr val="1E293B"/>
-                </a:solidFill>
-              </a:defRPr>
-            </a:pPr>
-            <a:r>
-              <a:t>• Real-Time Audio Player</a:t>
-            </a:r>
-          </a:p>
-          <a:p>
-            <a:pPr>
-              <a:spcAft>
-                <a:spcPts val="1000"/>
-              </a:spcAft>
-              <a:defRPr sz="1300">
-                <a:solidFill>
-                  <a:srgbClr val="1E293B"/>
-                </a:solidFill>
-              </a:defRPr>
-            </a:pPr>
-            <a:r>
-              <a:t>• Screen-Reader DOM Layout</a:t>
-            </a:r>
-          </a:p>
-          <a:p>
-            <a:pPr>
-              <a:spcAft>
-                <a:spcPts val="1000"/>
-              </a:spcAft>
-              <a:defRPr sz="1300">
-                <a:solidFill>
-                  <a:srgbClr val="1E293B"/>
-                </a:solidFill>
-              </a:defRPr>
-            </a:pPr>
-            <a:r>
-              <a:t>• Peer-to-Peer Rewards Hub</a:t>
+              </a:rPr>
+              <a:t>Neural Network Module
+</a:t>
+            </a:r>
+            <a:r>
+              <a:rPr sz="1200">
+                <a:solidFill>
+                  <a:srgbClr val="10B981"/>
+                </a:solidFill>
+              </a:rPr>
+              <a:t>Backpropagation and Convolutional edge detections mapped into regional vernaculars.</a:t>
             </a:r>
           </a:p>
         </p:txBody>
@@ -5450,7 +5205,7 @@
           <a:lstStyle/>
           <a:p>
             <a:pPr>
-              <a:defRPr sz="3600" b="1">
+              <a:defRPr sz="3200" b="1">
                 <a:solidFill>
                   <a:srgbClr val="0A192F"/>
                 </a:solidFill>
@@ -5458,7 +5213,7 @@
               </a:defRPr>
             </a:pPr>
             <a:r>
-              <a:t>The Scalable Technology Stack</a:t>
+              <a:t>SkillBridge: Dynamic Mastery Diagnostics</a:t>
             </a:r>
           </a:p>
         </p:txBody>
@@ -5471,8 +5226,8 @@
         </p:nvSpPr>
         <p:spPr>
           <a:xfrm>
-            <a:off x="731520" y="1645920"/>
-            <a:ext cx="3291840" cy="4389120"/>
+            <a:off x="731520" y="1371600"/>
+            <a:ext cx="5120640" cy="4754880"/>
           </a:xfrm>
           <a:prstGeom prst="roundRect">
             <a:avLst/>
@@ -5482,7 +5237,7 @@
           </a:solidFill>
           <a:ln w="19050">
             <a:solidFill>
-              <a:srgbClr val="10B981"/>
+              <a:srgbClr val="0A192F"/>
             </a:solidFill>
           </a:ln>
         </p:spPr>
@@ -5516,8 +5271,8 @@
         </p:nvSpPr>
         <p:spPr>
           <a:xfrm>
-            <a:off x="868680" y="1828800"/>
-            <a:ext cx="3017520" cy="4023360"/>
+            <a:off x="914400" y="1554480"/>
+            <a:ext cx="4754880" cy="4389120"/>
           </a:xfrm>
           <a:prstGeom prst="rect">
             <a:avLst/>
@@ -5532,9 +5287,9 @@
           <a:p>
             <a:pPr>
               <a:spcAft>
-                <a:spcPts val="600"/>
+                <a:spcPts val="1500"/>
               </a:spcAft>
-              <a:defRPr b="1" sz="1600">
+              <a:defRPr sz="2000" b="1">
                 <a:solidFill>
                   <a:srgbClr val="0A192F"/>
                 </a:solidFill>
@@ -5542,103 +5297,76 @@
               </a:defRPr>
             </a:pPr>
             <a:r>
-              <a:t>FRONTEND (REACT)</a:t>
+              <a:t>Evaluation &amp; Feedback Loop:</a:t>
             </a:r>
           </a:p>
           <a:p>
             <a:pPr>
               <a:spcAft>
-                <a:spcPts val="1400"/>
+                <a:spcPts val="1200"/>
               </a:spcAft>
-              <a:defRPr i="1" sz="1100">
-                <a:solidFill>
-                  <a:srgbClr val="64748B"/>
-                </a:solidFill>
-                <a:latin typeface="Arial"/>
-              </a:defRPr>
-            </a:pPr>
-            <a:r>
-              <a:t>Highly accessible, interactive user interface.</a:t>
+            </a:pPr>
+            <a:r>
+              <a:rPr b="1" sz="1300">
+                <a:solidFill>
+                  <a:srgbClr val="0A192F"/>
+                </a:solidFill>
+              </a:rPr>
+              <a:t>• Adaptive Quiz Generation: </a:t>
+            </a:r>
+            <a:r>
+              <a:rPr sz="1300">
+                <a:solidFill>
+                  <a:srgbClr val="1E293B"/>
+                </a:solidFill>
+              </a:rPr>
+              <a:t> Automatically extracts key concepts from Gemini JSON structures to test memory, recall, and application.</a:t>
             </a:r>
           </a:p>
           <a:p>
             <a:pPr>
               <a:spcAft>
-                <a:spcPts val="800"/>
+                <a:spcPts val="1200"/>
               </a:spcAft>
-              <a:defRPr sz="1300">
+            </a:pPr>
+            <a:r>
+              <a:rPr b="1" sz="1300">
+                <a:solidFill>
+                  <a:srgbClr val="0A192F"/>
+                </a:solidFill>
+              </a:rPr>
+              <a:t>• Real-Time Mastery Mapping: </a:t>
+            </a:r>
+            <a:r>
+              <a:rPr sz="1300">
                 <a:solidFill>
                   <a:srgbClr val="1E293B"/>
                 </a:solidFill>
-                <a:latin typeface="Arial"/>
-              </a:defRPr>
-            </a:pPr>
-            <a:r>
-              <a:t>• React.js &amp; TypeScript</a:t>
+              </a:rPr>
+              <a:t> Missed questions are linked to specific node labels. The canvas updates node gap status automatically.</a:t>
             </a:r>
           </a:p>
           <a:p>
             <a:pPr>
               <a:spcAft>
-                <a:spcPts val="800"/>
+                <a:spcPts val="1200"/>
               </a:spcAft>
-              <a:defRPr sz="1300">
+            </a:pPr>
+            <a:r>
+              <a:rPr b="1" sz="1300">
+                <a:solidFill>
+                  <a:srgbClr val="0A192F"/>
+                </a:solidFill>
+              </a:rPr>
+              <a:t>• Mastery Color Coding: </a:t>
+            </a:r>
+            <a:r>
+              <a:rPr sz="1300">
                 <a:solidFill>
                   <a:srgbClr val="1E293B"/>
                 </a:solidFill>
-                <a:latin typeface="Arial"/>
-              </a:defRPr>
-            </a:pPr>
-            <a:r>
-              <a:t>• Tailwind CSS (Glassmorphism)</a:t>
-            </a:r>
-          </a:p>
-          <a:p>
-            <a:pPr>
-              <a:spcAft>
-                <a:spcPts val="800"/>
-              </a:spcAft>
-              <a:defRPr sz="1300">
-                <a:solidFill>
-                  <a:srgbClr val="1E293B"/>
-                </a:solidFill>
-                <a:latin typeface="Arial"/>
-              </a:defRPr>
-            </a:pPr>
-            <a:r>
-              <a:t>• HTML5 Canvas (VisualMind Graph)</a:t>
-            </a:r>
-          </a:p>
-          <a:p>
-            <a:pPr>
-              <a:spcAft>
-                <a:spcPts val="800"/>
-              </a:spcAft>
-              <a:defRPr sz="1300">
-                <a:solidFill>
-                  <a:srgbClr val="1E293B"/>
-                </a:solidFill>
-                <a:latin typeface="Arial"/>
-              </a:defRPr>
-            </a:pPr>
-            <a:r>
-              <a:t>• Web Speech API (STT Transcription)</a:t>
-            </a:r>
-          </a:p>
-          <a:p>
-            <a:pPr>
-              <a:spcAft>
-                <a:spcPts val="800"/>
-              </a:spcAft>
-              <a:defRPr sz="1300">
-                <a:solidFill>
-                  <a:srgbClr val="1E293B"/>
-                </a:solidFill>
-                <a:latin typeface="Arial"/>
-              </a:defRPr>
-            </a:pPr>
-            <a:r>
-              <a:t>• Web Speech API (TTS Vocalizer)</a:t>
+              </a:rPr>
+              <a:t> Mastered nodes turn green (Mastery); weak nodes turn orange (Mastery Gap) to direct student focus.</a:t>
             </a:r>
           </a:p>
         </p:txBody>
@@ -5651,18 +5379,18 @@
         </p:nvSpPr>
         <p:spPr>
           <a:xfrm>
-            <a:off x="4480560" y="1645920"/>
-            <a:ext cx="3291840" cy="4389120"/>
+            <a:off x="6217920" y="1371600"/>
+            <a:ext cx="5120640" cy="4754880"/>
           </a:xfrm>
           <a:prstGeom prst="roundRect">
             <a:avLst/>
           </a:prstGeom>
           <a:solidFill>
-            <a:srgbClr val="FFFFFF"/>
+            <a:srgbClr val="0A192F"/>
           </a:solidFill>
-          <a:ln w="19050">
+          <a:ln>
             <a:solidFill>
-              <a:srgbClr val="10B981"/>
+              <a:srgbClr val="0A192F"/>
             </a:solidFill>
           </a:ln>
         </p:spPr>
@@ -5696,8 +5424,8 @@
         </p:nvSpPr>
         <p:spPr>
           <a:xfrm>
-            <a:off x="4617720" y="1828800"/>
-            <a:ext cx="3017520" cy="4023360"/>
+            <a:off x="6400800" y="1554480"/>
+            <a:ext cx="4754880" cy="4389120"/>
           </a:xfrm>
           <a:prstGeom prst="rect">
             <a:avLst/>
@@ -5712,17 +5440,17 @@
           <a:p>
             <a:pPr>
               <a:spcAft>
-                <a:spcPts val="600"/>
+                <a:spcPts val="2000"/>
               </a:spcAft>
-              <a:defRPr b="1" sz="1600">
-                <a:solidFill>
-                  <a:srgbClr val="0A192F"/>
+              <a:defRPr sz="2000" b="1">
+                <a:solidFill>
+                  <a:srgbClr val="10B981"/>
                 </a:solidFill>
                 <a:latin typeface="Arial"/>
               </a:defRPr>
             </a:pPr>
             <a:r>
-              <a:t>BACKEND &amp; AI</a:t>
+              <a:t>Mastery Output Features:</a:t>
             </a:r>
           </a:p>
           <a:p>
@@ -5730,179 +5458,23 @@
               <a:spcAft>
                 <a:spcPts val="1400"/>
               </a:spcAft>
-              <a:defRPr i="1" sz="1100">
-                <a:solidFill>
-                  <a:srgbClr val="64748B"/>
-                </a:solidFill>
-                <a:latin typeface="Arial"/>
-              </a:defRPr>
-            </a:pPr>
-            <a:r>
-              <a:t>Express middleware and Gemini LLM integrations.</a:t>
-            </a:r>
-          </a:p>
-          <a:p>
-            <a:pPr>
-              <a:spcAft>
-                <a:spcPts val="800"/>
-              </a:spcAft>
-              <a:defRPr sz="1300">
-                <a:solidFill>
-                  <a:srgbClr val="1E293B"/>
-                </a:solidFill>
-                <a:latin typeface="Arial"/>
-              </a:defRPr>
-            </a:pPr>
-            <a:r>
-              <a:t>• Node.js &amp; Express.js</a:t>
-            </a:r>
-          </a:p>
-          <a:p>
-            <a:pPr>
-              <a:spcAft>
-                <a:spcPts val="800"/>
-              </a:spcAft>
-              <a:defRPr sz="1300">
-                <a:solidFill>
-                  <a:srgbClr val="1E293B"/>
-                </a:solidFill>
-                <a:latin typeface="Arial"/>
-              </a:defRPr>
-            </a:pPr>
-            <a:r>
-              <a:t>• Google Gemini 2.5 Flash SDK</a:t>
-            </a:r>
-          </a:p>
-          <a:p>
-            <a:pPr>
-              <a:spcAft>
-                <a:spcPts val="800"/>
-              </a:spcAft>
-              <a:defRPr sz="1300">
-                <a:solidFill>
-                  <a:srgbClr val="1E293B"/>
-                </a:solidFill>
-                <a:latin typeface="Arial"/>
-              </a:defRPr>
-            </a:pPr>
-            <a:r>
-              <a:t>• Multer File Ingestor</a:t>
-            </a:r>
-          </a:p>
-          <a:p>
-            <a:pPr>
-              <a:spcAft>
-                <a:spcPts val="800"/>
-              </a:spcAft>
-              <a:defRPr sz="1300">
-                <a:solidFill>
-                  <a:srgbClr val="1E293B"/>
-                </a:solidFill>
-                <a:latin typeface="Arial"/>
-              </a:defRPr>
-            </a:pPr>
-            <a:r>
-              <a:t>• Dynamic Quiz Generator</a:t>
-            </a:r>
-          </a:p>
-          <a:p>
-            <a:pPr>
-              <a:spcAft>
-                <a:spcPts val="800"/>
-              </a:spcAft>
-              <a:defRPr sz="1300">
-                <a:solidFill>
-                  <a:srgbClr val="1E293B"/>
-                </a:solidFill>
-                <a:latin typeface="Arial"/>
-              </a:defRPr>
-            </a:pPr>
-            <a:r>
-              <a:t>• Dynamic Translation endpoints</a:t>
-            </a:r>
-          </a:p>
-        </p:txBody>
-      </p:sp>
-      <p:sp>
-        <p:nvSpPr>
-          <p:cNvPr id="9" name="Rounded Rectangle 8"/>
-          <p:cNvSpPr/>
-          <p:nvPr/>
-        </p:nvSpPr>
-        <p:spPr>
-          <a:xfrm>
-            <a:off x="8229600" y="1645920"/>
-            <a:ext cx="3291840" cy="4389120"/>
-          </a:xfrm>
-          <a:prstGeom prst="roundRect">
-            <a:avLst/>
-          </a:prstGeom>
-          <a:solidFill>
-            <a:srgbClr val="FFFFFF"/>
-          </a:solidFill>
-          <a:ln w="19050">
-            <a:solidFill>
-              <a:srgbClr val="10B981"/>
-            </a:solidFill>
-          </a:ln>
-        </p:spPr>
-        <p:style>
-          <a:lnRef idx="1">
-            <a:schemeClr val="accent1"/>
-          </a:lnRef>
-          <a:fillRef idx="3">
-            <a:schemeClr val="accent1"/>
-          </a:fillRef>
-          <a:effectRef idx="2">
-            <a:schemeClr val="accent1"/>
-          </a:effectRef>
-          <a:fontRef idx="minor">
-            <a:schemeClr val="lt1"/>
-          </a:fontRef>
-        </p:style>
-        <p:txBody>
-          <a:bodyPr rtlCol="0" anchor="ctr"/>
-          <a:lstStyle/>
-          <a:p>
-            <a:pPr algn="ctr"/>
-          </a:p>
-        </p:txBody>
-      </p:sp>
-      <p:sp>
-        <p:nvSpPr>
-          <p:cNvPr id="10" name="TextBox 9"/>
-          <p:cNvSpPr txBox="1"/>
-          <p:nvPr/>
-        </p:nvSpPr>
-        <p:spPr>
-          <a:xfrm>
-            <a:off x="8366760" y="1828800"/>
-            <a:ext cx="3017520" cy="4023360"/>
-          </a:xfrm>
-          <a:prstGeom prst="rect">
-            <a:avLst/>
-          </a:prstGeom>
-          <a:noFill/>
-        </p:spPr>
-        <p:txBody>
-          <a:bodyPr wrap="square">
-            <a:spAutoFit/>
-          </a:bodyPr>
-          <a:lstStyle/>
-          <a:p>
-            <a:pPr>
-              <a:spcAft>
-                <a:spcPts val="600"/>
-              </a:spcAft>
-              <a:defRPr b="1" sz="1600">
-                <a:solidFill>
-                  <a:srgbClr val="0A192F"/>
-                </a:solidFill>
-                <a:latin typeface="Arial"/>
-              </a:defRPr>
-            </a:pPr>
-            <a:r>
-              <a:t>UTILITIES &amp; DEPLOY</a:t>
+            </a:pPr>
+            <a:r>
+              <a:rPr b="1" sz="1500">
+                <a:solidFill>
+                  <a:srgbClr val="FFFFFF"/>
+                </a:solidFill>
+              </a:rPr>
+              <a:t>SVG Concept Mastery Chart
+</a:t>
+            </a:r>
+            <a:r>
+              <a:rPr sz="1200">
+                <a:solidFill>
+                  <a:srgbClr val="10B981"/>
+                </a:solidFill>
+              </a:rPr>
+              <a:t>Renders dynamic visual bar charts tracking core subconcepts and percentage scores automatically.</a:t>
             </a:r>
           </a:p>
           <a:p>
@@ -5910,95 +5482,23 @@
               <a:spcAft>
                 <a:spcPts val="1400"/>
               </a:spcAft>
-              <a:defRPr i="1" sz="1100">
-                <a:solidFill>
-                  <a:srgbClr val="64748B"/>
-                </a:solidFill>
-                <a:latin typeface="Arial"/>
-              </a:defRPr>
-            </a:pPr>
-            <a:r>
-              <a:t>Staging, documentation, and cloud execution.</a:t>
-            </a:r>
-          </a:p>
-          <a:p>
-            <a:pPr>
-              <a:spcAft>
-                <a:spcPts val="800"/>
-              </a:spcAft>
-              <a:defRPr sz="1300">
-                <a:solidFill>
-                  <a:srgbClr val="1E293B"/>
-                </a:solidFill>
-                <a:latin typeface="Arial"/>
-              </a:defRPr>
-            </a:pPr>
-            <a:r>
-              <a:t>• reportlab (PDF Compiler)</a:t>
-            </a:r>
-          </a:p>
-          <a:p>
-            <a:pPr>
-              <a:spcAft>
-                <a:spcPts val="800"/>
-              </a:spcAft>
-              <a:defRPr sz="1300">
-                <a:solidFill>
-                  <a:srgbClr val="1E293B"/>
-                </a:solidFill>
-                <a:latin typeface="Arial"/>
-              </a:defRPr>
-            </a:pPr>
-            <a:r>
-              <a:t>• python-pptx (Deck Generator)</a:t>
-            </a:r>
-          </a:p>
-          <a:p>
-            <a:pPr>
-              <a:spcAft>
-                <a:spcPts val="800"/>
-              </a:spcAft>
-              <a:defRPr sz="1300">
-                <a:solidFill>
-                  <a:srgbClr val="1E293B"/>
-                </a:solidFill>
-                <a:latin typeface="Arial"/>
-              </a:defRPr>
-            </a:pPr>
-            <a:r>
-              <a:t>• Git &amp; GitHub Version Control</a:t>
-            </a:r>
-          </a:p>
-          <a:p>
-            <a:pPr>
-              <a:spcAft>
-                <a:spcPts val="800"/>
-              </a:spcAft>
-              <a:defRPr sz="1300">
-                <a:solidFill>
-                  <a:srgbClr val="1E293B"/>
-                </a:solidFill>
-                <a:latin typeface="Arial"/>
-              </a:defRPr>
-            </a:pPr>
-            <a:r>
-              <a:t>• Render Cloud Web Services</a:t>
-            </a:r>
-          </a:p>
-          <a:p>
-            <a:pPr>
-              <a:spcAft>
-                <a:spcPts val="800"/>
-              </a:spcAft>
-              <a:defRPr sz="1300">
-                <a:solidFill>
-                  <a:srgbClr val="1E293B"/>
-                </a:solidFill>
-                <a:latin typeface="Arial"/>
-              </a:defRPr>
-            </a:pPr>
-            <a:r>
-              <a:t>• Unified MERN static delivery</a:t>
+            </a:pPr>
+            <a:r>
+              <a:rPr b="1" sz="1500">
+                <a:solidFill>
+                  <a:srgbClr val="FFFFFF"/>
+                </a:solidFill>
+              </a:rPr>
+              <a:t>Adaptive Study Checklist
+</a:t>
+            </a:r>
+            <a:r>
+              <a:rPr sz="1200">
+                <a:solidFill>
+                  <a:srgbClr val="10B981"/>
+                </a:solidFill>
+              </a:rPr>
+              <a:t>Builds a checklist of missed nodes (e.g. 'Review Calvin Cycle' or 'Examine thylakoid'), giving students targeted study instructions.</a:t>
             </a:r>
           </a:p>
         </p:txBody>
@@ -6134,7 +5634,7 @@
           <a:lstStyle/>
           <a:p>
             <a:pPr>
-              <a:defRPr sz="3600" b="1">
+              <a:defRPr sz="3200" b="1">
                 <a:solidFill>
                   <a:srgbClr val="0A192F"/>
                 </a:solidFill>
@@ -6142,7 +5642,7 @@
               </a:defRPr>
             </a:pPr>
             <a:r>
-              <a:t>EduAccess &amp; Social Impact</a:t>
+              <a:t>EduAccess: Inclusivity &amp; Accessibility Panel</a:t>
             </a:r>
           </a:p>
         </p:txBody>
@@ -6163,8 +5663,8 @@
         </p:blipFill>
         <p:spPr>
           <a:xfrm>
-            <a:off x="731520" y="1463040"/>
-            <a:ext cx="5120640" cy="4389120"/>
+            <a:off x="731520" y="1371600"/>
+            <a:ext cx="4572000" cy="4754880"/>
           </a:xfrm>
           <a:prstGeom prst="rect">
             <a:avLst/>
@@ -6179,8 +5679,8 @@
         </p:nvSpPr>
         <p:spPr>
           <a:xfrm>
-            <a:off x="6217920" y="1463040"/>
-            <a:ext cx="5212080" cy="4389120"/>
+            <a:off x="5669280" y="1371600"/>
+            <a:ext cx="5760720" cy="4754880"/>
           </a:xfrm>
           <a:prstGeom prst="roundRect">
             <a:avLst/>
@@ -6224,8 +5724,8 @@
         </p:nvSpPr>
         <p:spPr>
           <a:xfrm>
-            <a:off x="6492240" y="1645920"/>
-            <a:ext cx="4663440" cy="4023360"/>
+            <a:off x="5852160" y="1554480"/>
+            <a:ext cx="5394960" cy="4389120"/>
           </a:xfrm>
           <a:prstGeom prst="rect">
             <a:avLst/>
@@ -6240,7 +5740,7 @@
           <a:p>
             <a:pPr>
               <a:spcAft>
-                <a:spcPts val="1600"/>
+                <a:spcPts val="1200"/>
               </a:spcAft>
               <a:defRPr sz="2000" b="1">
                 <a:solidFill>
@@ -6250,7 +5750,7 @@
               </a:defRPr>
             </a:pPr>
             <a:r>
-              <a:t>Designing for Universal Inclusion:</a:t>
+              <a:t>Accessibility Enhancements:</a:t>
             </a:r>
           </a:p>
           <a:p>
@@ -6262,10 +5762,10 @@
             <a:r>
               <a:rPr b="1" sz="1300">
                 <a:solidFill>
-                  <a:srgbClr val="059669"/>
+                  <a:srgbClr val="0A192F"/>
                 </a:solidFill>
               </a:rPr>
-              <a:t>• Voice Control Integration:</a:t>
+              <a:t>• Dyslexia Font Mode: </a:t>
             </a:r>
             <a:r>
               <a:rPr sz="1300">
@@ -6273,7 +5773,7 @@
                   <a:srgbClr val="1E293B"/>
                 </a:solidFill>
               </a:rPr>
-              <a:t> Screen-free interaction models allowing visually impaired students to dictate notes, navigate screens, and search topic nodes using spoken queries.</a:t>
+              <a:t> Switches styles to OpenDyslexic character spacing with heavier bottom weights, decreasing letter confusion.</a:t>
             </a:r>
           </a:p>
           <a:p>
@@ -6285,10 +5785,10 @@
             <a:r>
               <a:rPr b="1" sz="1300">
                 <a:solidFill>
-                  <a:srgbClr val="059669"/>
+                  <a:srgbClr val="0A192F"/>
                 </a:solidFill>
               </a:rPr>
-              <a:t>• Neurodiverse Mode:</a:t>
+              <a:t>• ADHD Focus Ruler: </a:t>
             </a:r>
             <a:r>
               <a:rPr sz="1300">
@@ -6296,7 +5796,7 @@
                   <a:srgbClr val="1E293B"/>
                 </a:solidFill>
               </a:rPr>
-              <a:t> Auto-simplifies dense jargon into structured, high-contrast summaries with minimized distraction elements.</a:t>
+              <a:t> Darkens screen segments and renders a horizontal highlighting ruler following the mouse cursor to boost concentration.</a:t>
             </a:r>
           </a:p>
           <a:p>
@@ -6308,10 +5808,10 @@
             <a:r>
               <a:rPr b="1" sz="1300">
                 <a:solidFill>
-                  <a:srgbClr val="059669"/>
+                  <a:srgbClr val="0A192F"/>
                 </a:solidFill>
               </a:rPr>
-              <a:t>• Expected Impact:</a:t>
+              <a:t>• Contrast &amp; Color Blind Filters: </a:t>
             </a:r>
             <a:r>
               <a:rPr sz="1300">
@@ -6319,7 +5819,30 @@
                   <a:srgbClr val="1E293B"/>
                 </a:solidFill>
               </a:rPr>
-              <a:t> Bridges language-medium gaps for up to 10M+ Indian students annually; reduces prep time for exam prep by 40%; provides a democratic level playing field for diverse abilities.</a:t>
+              <a:t> Injects real-time SVG matrix color filters (Protanopia, Deuteranopia, Tritanopia) directly into the DOM.</a:t>
+            </a:r>
+          </a:p>
+          <a:p>
+            <a:pPr>
+              <a:spcAft>
+                <a:spcPts val="1000"/>
+              </a:spcAft>
+            </a:pPr>
+            <a:r>
+              <a:rPr b="1" sz="1300">
+                <a:solidFill>
+                  <a:srgbClr val="0A192F"/>
+                </a:solidFill>
+              </a:rPr>
+              <a:t>• Voice Command Navigation: </a:t>
+            </a:r>
+            <a:r>
+              <a:rPr sz="1300">
+                <a:solidFill>
+                  <a:srgbClr val="1E293B"/>
+                </a:solidFill>
+              </a:rPr>
+              <a:t> Captures commands like 'open quiz', 'explain superposition' to control the interface hands-free.</a:t>
             </a:r>
           </a:p>
         </p:txBody>
@@ -6357,11 +5880,11 @@
             <a:avLst/>
           </a:prstGeom>
           <a:solidFill>
-            <a:srgbClr val="0A192F"/>
+            <a:srgbClr val="F8FAFC"/>
           </a:solidFill>
           <a:ln>
             <a:solidFill>
-              <a:srgbClr val="0A192F"/>
+              <a:srgbClr val="F8FAFC"/>
             </a:solidFill>
           </a:ln>
         </p:spPr>
@@ -6455,39 +5978,39 @@
           <a:lstStyle/>
           <a:p>
             <a:pPr>
-              <a:defRPr sz="3600" b="1">
-                <a:solidFill>
-                  <a:srgbClr val="FFFFFF"/>
+              <a:defRPr sz="3200" b="1">
+                <a:solidFill>
+                  <a:srgbClr val="0A192F"/>
                 </a:solidFill>
                 <a:latin typeface="Arial"/>
               </a:defRPr>
             </a:pPr>
             <a:r>
-              <a:t>Development Roadmap &amp; Milestones</a:t>
-            </a:r>
-          </a:p>
-        </p:txBody>
-      </p:sp>
-      <p:sp>
-        <p:nvSpPr>
-          <p:cNvPr id="5" name="Rectangle 4"/>
+              <a:t>System Architecture &amp; Scalability</a:t>
+            </a:r>
+          </a:p>
+        </p:txBody>
+      </p:sp>
+      <p:sp>
+        <p:nvSpPr>
+          <p:cNvPr id="5" name="Rounded Rectangle 4"/>
           <p:cNvSpPr/>
           <p:nvPr/>
         </p:nvSpPr>
         <p:spPr>
           <a:xfrm>
-            <a:off x="1371600" y="3200400"/>
-            <a:ext cx="9144000" cy="73152"/>
-          </a:xfrm>
-          <a:prstGeom prst="rect">
+            <a:off x="731520" y="1645920"/>
+            <a:ext cx="3291840" cy="4389120"/>
+          </a:xfrm>
+          <a:prstGeom prst="roundRect">
             <a:avLst/>
           </a:prstGeom>
           <a:solidFill>
-            <a:srgbClr val="059669"/>
+            <a:srgbClr val="FFFFFF"/>
           </a:solidFill>
-          <a:ln>
+          <a:ln w="19050">
             <a:solidFill>
-              <a:srgbClr val="059669"/>
+              <a:srgbClr val="0A192F"/>
             </a:solidFill>
           </a:ln>
         </p:spPr>
@@ -6515,20 +6038,276 @@
       </p:sp>
       <p:sp>
         <p:nvSpPr>
-          <p:cNvPr id="6" name="Rounded Rectangle 5"/>
+          <p:cNvPr id="6" name="TextBox 5"/>
+          <p:cNvSpPr txBox="1"/>
+          <p:nvPr/>
+        </p:nvSpPr>
+        <p:spPr>
+          <a:xfrm>
+            <a:off x="822960" y="1828800"/>
+            <a:ext cx="3108960" cy="4023360"/>
+          </a:xfrm>
+          <a:prstGeom prst="rect">
+            <a:avLst/>
+          </a:prstGeom>
+          <a:noFill/>
+        </p:spPr>
+        <p:txBody>
+          <a:bodyPr wrap="square">
+            <a:spAutoFit/>
+          </a:bodyPr>
+          <a:lstStyle/>
+          <a:p>
+            <a:pPr>
+              <a:spcAft>
+                <a:spcPts val="1200"/>
+              </a:spcAft>
+              <a:defRPr b="1" sz="1500">
+                <a:solidFill>
+                  <a:srgbClr val="0A192F"/>
+                </a:solidFill>
+              </a:defRPr>
+            </a:pPr>
+            <a:r>
+              <a:t>1. INGESTION LAYER</a:t>
+            </a:r>
+          </a:p>
+          <a:p>
+            <a:pPr>
+              <a:spcAft>
+                <a:spcPts val="800"/>
+              </a:spcAft>
+              <a:defRPr sz="1200">
+                <a:solidFill>
+                  <a:srgbClr val="1E293B"/>
+                </a:solidFill>
+              </a:defRPr>
+            </a:pPr>
+            <a:r>
+              <a:t>• HTML5 Audio Microphone Input</a:t>
+            </a:r>
+          </a:p>
+          <a:p>
+            <a:pPr>
+              <a:spcAft>
+                <a:spcPts val="800"/>
+              </a:spcAft>
+              <a:defRPr sz="1200">
+                <a:solidFill>
+                  <a:srgbClr val="1E293B"/>
+                </a:solidFill>
+              </a:defRPr>
+            </a:pPr>
+            <a:r>
+              <a:t>• PDF/TXT Study Notes uploads</a:t>
+            </a:r>
+          </a:p>
+          <a:p>
+            <a:pPr>
+              <a:spcAft>
+                <a:spcPts val="800"/>
+              </a:spcAft>
+              <a:defRPr sz="1200">
+                <a:solidFill>
+                  <a:srgbClr val="1E293B"/>
+                </a:solidFill>
+              </a:defRPr>
+            </a:pPr>
+            <a:r>
+              <a:t>• SpeechRecognition voice command capture (native browser API)</a:t>
+            </a:r>
+          </a:p>
+          <a:p>
+            <a:pPr>
+              <a:spcAft>
+                <a:spcPts val="800"/>
+              </a:spcAft>
+              <a:defRPr sz="1200">
+                <a:solidFill>
+                  <a:srgbClr val="1E293B"/>
+                </a:solidFill>
+              </a:defRPr>
+            </a:pPr>
+            <a:r>
+              <a:t>• Stored environment API keys</a:t>
+            </a:r>
+          </a:p>
+        </p:txBody>
+      </p:sp>
+      <p:sp>
+        <p:nvSpPr>
+          <p:cNvPr id="7" name="Rounded Rectangle 6"/>
           <p:cNvSpPr/>
           <p:nvPr/>
         </p:nvSpPr>
         <p:spPr>
           <a:xfrm>
-            <a:off x="731520" y="1645920"/>
-            <a:ext cx="2468880" cy="4114800"/>
+            <a:off x="4389120" y="1645920"/>
+            <a:ext cx="3291840" cy="4389120"/>
           </a:xfrm>
           <a:prstGeom prst="roundRect">
             <a:avLst/>
           </a:prstGeom>
           <a:solidFill>
-            <a:srgbClr val="172A45"/>
+            <a:srgbClr val="0A192F"/>
+          </a:solidFill>
+          <a:ln>
+            <a:solidFill>
+              <a:srgbClr val="0A192F"/>
+            </a:solidFill>
+          </a:ln>
+        </p:spPr>
+        <p:style>
+          <a:lnRef idx="1">
+            <a:schemeClr val="accent1"/>
+          </a:lnRef>
+          <a:fillRef idx="3">
+            <a:schemeClr val="accent1"/>
+          </a:fillRef>
+          <a:effectRef idx="2">
+            <a:schemeClr val="accent1"/>
+          </a:effectRef>
+          <a:fontRef idx="minor">
+            <a:schemeClr val="lt1"/>
+          </a:fontRef>
+        </p:style>
+        <p:txBody>
+          <a:bodyPr rtlCol="0" anchor="ctr"/>
+          <a:lstStyle/>
+          <a:p>
+            <a:pPr algn="ctr"/>
+          </a:p>
+        </p:txBody>
+      </p:sp>
+      <p:sp>
+        <p:nvSpPr>
+          <p:cNvPr id="8" name="TextBox 7"/>
+          <p:cNvSpPr txBox="1"/>
+          <p:nvPr/>
+        </p:nvSpPr>
+        <p:spPr>
+          <a:xfrm>
+            <a:off x="4480560" y="1828800"/>
+            <a:ext cx="3108960" cy="4023360"/>
+          </a:xfrm>
+          <a:prstGeom prst="rect">
+            <a:avLst/>
+          </a:prstGeom>
+          <a:noFill/>
+        </p:spPr>
+        <p:txBody>
+          <a:bodyPr wrap="square">
+            <a:spAutoFit/>
+          </a:bodyPr>
+          <a:lstStyle/>
+          <a:p>
+            <a:pPr>
+              <a:spcAft>
+                <a:spcPts val="1200"/>
+              </a:spcAft>
+              <a:defRPr b="1" sz="1500">
+                <a:solidFill>
+                  <a:srgbClr val="10B981"/>
+                </a:solidFill>
+              </a:defRPr>
+            </a:pPr>
+            <a:r>
+              <a:t>2. AI ORCHESTRATION</a:t>
+            </a:r>
+          </a:p>
+          <a:p>
+            <a:pPr>
+              <a:spcAft>
+                <a:spcPts val="800"/>
+              </a:spcAft>
+              <a:defRPr sz="1200">
+                <a:solidFill>
+                  <a:srgbClr val="FFFFFF"/>
+                </a:solidFill>
+              </a:defRPr>
+            </a:pPr>
+            <a:r>
+              <a:t>• Node.js &amp; Express.js server</a:t>
+            </a:r>
+          </a:p>
+          <a:p>
+            <a:pPr>
+              <a:spcAft>
+                <a:spcPts val="800"/>
+              </a:spcAft>
+              <a:defRPr sz="1200">
+                <a:solidFill>
+                  <a:srgbClr val="FFFFFF"/>
+                </a:solidFill>
+              </a:defRPr>
+            </a:pPr>
+            <a:r>
+              <a:t>• Google Generative AI v1beta SDK</a:t>
+            </a:r>
+          </a:p>
+          <a:p>
+            <a:pPr>
+              <a:spcAft>
+                <a:spcPts val="800"/>
+              </a:spcAft>
+              <a:defRPr sz="1200">
+                <a:solidFill>
+                  <a:srgbClr val="FFFFFF"/>
+                </a:solidFill>
+              </a:defRPr>
+            </a:pPr>
+            <a:r>
+              <a:t>• Gemini 2.5 Flash model</a:t>
+            </a:r>
+          </a:p>
+          <a:p>
+            <a:pPr>
+              <a:spcAft>
+                <a:spcPts val="800"/>
+              </a:spcAft>
+              <a:defRPr sz="1200">
+                <a:solidFill>
+                  <a:srgbClr val="FFFFFF"/>
+                </a:solidFill>
+              </a:defRPr>
+            </a:pPr>
+            <a:r>
+              <a:t>• Custom prompts extracting structured JSON graphs &amp; MCQ datasets</a:t>
+            </a:r>
+          </a:p>
+          <a:p>
+            <a:pPr>
+              <a:spcAft>
+                <a:spcPts val="800"/>
+              </a:spcAft>
+              <a:defRPr sz="1200">
+                <a:solidFill>
+                  <a:srgbClr val="FFFFFF"/>
+                </a:solidFill>
+              </a:defRPr>
+            </a:pPr>
+            <a:r>
+              <a:t>• Keyword-based Mock Sandbox routers</a:t>
+            </a:r>
+          </a:p>
+        </p:txBody>
+      </p:sp>
+      <p:sp>
+        <p:nvSpPr>
+          <p:cNvPr id="9" name="Rounded Rectangle 8"/>
+          <p:cNvSpPr/>
+          <p:nvPr/>
+        </p:nvSpPr>
+        <p:spPr>
+          <a:xfrm>
+            <a:off x="8046720" y="1645920"/>
+            <a:ext cx="3383280" cy="4389120"/>
+          </a:xfrm>
+          <a:prstGeom prst="roundRect">
+            <a:avLst/>
+          </a:prstGeom>
+          <a:solidFill>
+            <a:srgbClr val="FFFFFF"/>
           </a:solidFill>
           <a:ln w="19050">
             <a:solidFill>
@@ -6560,14 +6339,14 @@
       </p:sp>
       <p:sp>
         <p:nvSpPr>
-          <p:cNvPr id="7" name="TextBox 6"/>
+          <p:cNvPr id="10" name="TextBox 9"/>
           <p:cNvSpPr txBox="1"/>
           <p:nvPr/>
         </p:nvSpPr>
         <p:spPr>
           <a:xfrm>
-            <a:off x="822960" y="1828800"/>
-            <a:ext cx="2286000" cy="3749039"/>
+            <a:off x="8138160" y="1828800"/>
+            <a:ext cx="3200400" cy="4023360"/>
           </a:xfrm>
           <a:prstGeom prst="rect">
             <a:avLst/>
@@ -6582,448 +6361,76 @@
           <a:p>
             <a:pPr>
               <a:spcAft>
-                <a:spcPts val="400"/>
+                <a:spcPts val="1200"/>
               </a:spcAft>
-              <a:defRPr b="1" sz="1800">
-                <a:solidFill>
-                  <a:srgbClr val="10B981"/>
+              <a:defRPr b="1" sz="1500">
+                <a:solidFill>
+                  <a:srgbClr val="0A192F"/>
                 </a:solidFill>
               </a:defRPr>
             </a:pPr>
             <a:r>
-              <a:t>ROUND 1</a:t>
+              <a:t>3. PRESENTATION LAYER</a:t>
             </a:r>
           </a:p>
           <a:p>
             <a:pPr>
               <a:spcAft>
-                <a:spcPts val="1500"/>
+                <a:spcPts val="800"/>
               </a:spcAft>
-              <a:defRPr i="1" sz="1200">
-                <a:solidFill>
-                  <a:srgbClr val="FFFFFF"/>
+              <a:defRPr sz="1200">
+                <a:solidFill>
+                  <a:srgbClr val="1E293B"/>
                 </a:solidFill>
               </a:defRPr>
             </a:pPr>
             <a:r>
-              <a:t>June 17 - 18</a:t>
-            </a:r>
-          </a:p>
-          <a:p>
-            <a:pPr>
+              <a:t>• React dynamic canvas canvas nodes</a:t>
+            </a:r>
+          </a:p>
+          <a:p>
+            <a:pPr>
+              <a:spcAft>
+                <a:spcPts val="800"/>
+              </a:spcAft>
               <a:defRPr sz="1200">
                 <a:solidFill>
-                  <a:srgbClr val="FFFFFF"/>
+                  <a:srgbClr val="1E293B"/>
                 </a:solidFill>
               </a:defRPr>
             </a:pPr>
             <a:r>
-              <a:t>• Problem Statement identification</a:t>
-            </a:r>
-            <a:br/>
-            <a:r>
-              <a:t>• Idea formulation &amp; PPTX deck</a:t>
-            </a:r>
-            <a:br/>
-            <a:r>
-              <a:t>• Concept validation</a:t>
-            </a:r>
-            <a:br/>
-            <a:r>
-              <a:t>• Proposal Submission</a:t>
-            </a:r>
-          </a:p>
-        </p:txBody>
-      </p:sp>
-      <p:sp>
-        <p:nvSpPr>
-          <p:cNvPr id="8" name="Rounded Rectangle 7"/>
-          <p:cNvSpPr/>
-          <p:nvPr/>
-        </p:nvSpPr>
-        <p:spPr>
-          <a:xfrm>
-            <a:off x="3474720" y="1645920"/>
-            <a:ext cx="2468880" cy="4114800"/>
-          </a:xfrm>
-          <a:prstGeom prst="roundRect">
-            <a:avLst/>
-          </a:prstGeom>
-          <a:solidFill>
-            <a:srgbClr val="172A45"/>
-          </a:solidFill>
-          <a:ln w="19050">
-            <a:solidFill>
-              <a:srgbClr val="10B981"/>
-            </a:solidFill>
-          </a:ln>
-        </p:spPr>
-        <p:style>
-          <a:lnRef idx="1">
-            <a:schemeClr val="accent1"/>
-          </a:lnRef>
-          <a:fillRef idx="3">
-            <a:schemeClr val="accent1"/>
-          </a:fillRef>
-          <a:effectRef idx="2">
-            <a:schemeClr val="accent1"/>
-          </a:effectRef>
-          <a:fontRef idx="minor">
-            <a:schemeClr val="lt1"/>
-          </a:fontRef>
-        </p:style>
-        <p:txBody>
-          <a:bodyPr rtlCol="0" anchor="ctr"/>
-          <a:lstStyle/>
-          <a:p>
-            <a:pPr algn="ctr"/>
-          </a:p>
-        </p:txBody>
-      </p:sp>
-      <p:sp>
-        <p:nvSpPr>
-          <p:cNvPr id="9" name="TextBox 8"/>
-          <p:cNvSpPr txBox="1"/>
-          <p:nvPr/>
-        </p:nvSpPr>
-        <p:spPr>
-          <a:xfrm>
-            <a:off x="3566160" y="1828800"/>
-            <a:ext cx="2286000" cy="3749039"/>
-          </a:xfrm>
-          <a:prstGeom prst="rect">
-            <a:avLst/>
-          </a:prstGeom>
-          <a:noFill/>
-        </p:spPr>
-        <p:txBody>
-          <a:bodyPr wrap="square">
-            <a:spAutoFit/>
-          </a:bodyPr>
-          <a:lstStyle/>
+              <a:t>• Dynamic color state variables mapping mastery metrics</a:t>
+            </a:r>
+          </a:p>
           <a:p>
             <a:pPr>
               <a:spcAft>
-                <a:spcPts val="400"/>
+                <a:spcPts val="800"/>
               </a:spcAft>
-              <a:defRPr b="1" sz="1800">
-                <a:solidFill>
-                  <a:srgbClr val="10B981"/>
+              <a:defRPr sz="1200">
+                <a:solidFill>
+                  <a:srgbClr val="1E293B"/>
                 </a:solidFill>
               </a:defRPr>
             </a:pPr>
             <a:r>
-              <a:t>ROUND 2</a:t>
+              <a:t>• Asynchronous voice loader triggering SpeechSynthesis (TTS)</a:t>
             </a:r>
           </a:p>
           <a:p>
             <a:pPr>
               <a:spcAft>
-                <a:spcPts val="1500"/>
+                <a:spcPts val="800"/>
               </a:spcAft>
-              <a:defRPr i="1" sz="1200">
-                <a:solidFill>
-                  <a:srgbClr val="FFFFFF"/>
+              <a:defRPr sz="1200">
+                <a:solidFill>
+                  <a:srgbClr val="1E293B"/>
                 </a:solidFill>
               </a:defRPr>
             </a:pPr>
             <a:r>
-              <a:t>June 20 - 22</a:t>
-            </a:r>
-          </a:p>
-          <a:p>
-            <a:pPr>
-              <a:defRPr sz="1200">
-                <a:solidFill>
-                  <a:srgbClr val="FFFFFF"/>
-                </a:solidFill>
-              </a:defRPr>
-            </a:pPr>
-            <a:r>
-              <a:t>• Express/Node backend config</a:t>
-            </a:r>
-            <a:br/>
-            <a:r>
-              <a:t>• Whisper &amp; Gemini integrations</a:t>
-            </a:r>
-            <a:br/>
-            <a:r>
-              <a:t>• Interactive canvas UI prototype</a:t>
-            </a:r>
-            <a:br/>
-            <a:r>
-              <a:t>• Source code &amp; Video submission</a:t>
-            </a:r>
-          </a:p>
-        </p:txBody>
-      </p:sp>
-      <p:sp>
-        <p:nvSpPr>
-          <p:cNvPr id="10" name="Rounded Rectangle 9"/>
-          <p:cNvSpPr/>
-          <p:nvPr/>
-        </p:nvSpPr>
-        <p:spPr>
-          <a:xfrm>
-            <a:off x="6217920" y="1645920"/>
-            <a:ext cx="2468880" cy="4114800"/>
-          </a:xfrm>
-          <a:prstGeom prst="roundRect">
-            <a:avLst/>
-          </a:prstGeom>
-          <a:solidFill>
-            <a:srgbClr val="172A45"/>
-          </a:solidFill>
-          <a:ln w="19050">
-            <a:solidFill>
-              <a:srgbClr val="10B981"/>
-            </a:solidFill>
-          </a:ln>
-        </p:spPr>
-        <p:style>
-          <a:lnRef idx="1">
-            <a:schemeClr val="accent1"/>
-          </a:lnRef>
-          <a:fillRef idx="3">
-            <a:schemeClr val="accent1"/>
-          </a:fillRef>
-          <a:effectRef idx="2">
-            <a:schemeClr val="accent1"/>
-          </a:effectRef>
-          <a:fontRef idx="minor">
-            <a:schemeClr val="lt1"/>
-          </a:fontRef>
-        </p:style>
-        <p:txBody>
-          <a:bodyPr rtlCol="0" anchor="ctr"/>
-          <a:lstStyle/>
-          <a:p>
-            <a:pPr algn="ctr"/>
-          </a:p>
-        </p:txBody>
-      </p:sp>
-      <p:sp>
-        <p:nvSpPr>
-          <p:cNvPr id="11" name="TextBox 10"/>
-          <p:cNvSpPr txBox="1"/>
-          <p:nvPr/>
-        </p:nvSpPr>
-        <p:spPr>
-          <a:xfrm>
-            <a:off x="6309360" y="1828800"/>
-            <a:ext cx="2286000" cy="3749039"/>
-          </a:xfrm>
-          <a:prstGeom prst="rect">
-            <a:avLst/>
-          </a:prstGeom>
-          <a:noFill/>
-        </p:spPr>
-        <p:txBody>
-          <a:bodyPr wrap="square">
-            <a:spAutoFit/>
-          </a:bodyPr>
-          <a:lstStyle/>
-          <a:p>
-            <a:pPr>
-              <a:spcAft>
-                <a:spcPts val="400"/>
-              </a:spcAft>
-              <a:defRPr b="1" sz="1800">
-                <a:solidFill>
-                  <a:srgbClr val="10B981"/>
-                </a:solidFill>
-              </a:defRPr>
-            </a:pPr>
-            <a:r>
-              <a:t>PHASE 3</a:t>
-            </a:r>
-          </a:p>
-          <a:p>
-            <a:pPr>
-              <a:spcAft>
-                <a:spcPts val="1500"/>
-              </a:spcAft>
-              <a:defRPr i="1" sz="1200">
-                <a:solidFill>
-                  <a:srgbClr val="FFFFFF"/>
-                </a:solidFill>
-              </a:defRPr>
-            </a:pPr>
-            <a:r>
-              <a:t>June 23 - 26</a:t>
-            </a:r>
-          </a:p>
-          <a:p>
-            <a:pPr>
-              <a:defRPr sz="1200">
-                <a:solidFill>
-                  <a:srgbClr val="FFFFFF"/>
-                </a:solidFill>
-              </a:defRPr>
-            </a:pPr>
-            <a:r>
-              <a:t>• Pilot testing &amp; bug fixes</a:t>
-            </a:r>
-            <a:br/>
-            <a:r>
-              <a:t>• Real-time socket connections</a:t>
-            </a:r>
-            <a:br/>
-            <a:r>
-              <a:t>• Demo polishing &amp; presentation compilation</a:t>
-            </a:r>
-          </a:p>
-        </p:txBody>
-      </p:sp>
-      <p:sp>
-        <p:nvSpPr>
-          <p:cNvPr id="12" name="Rounded Rectangle 11"/>
-          <p:cNvSpPr/>
-          <p:nvPr/>
-        </p:nvSpPr>
-        <p:spPr>
-          <a:xfrm>
-            <a:off x="8961120" y="1645920"/>
-            <a:ext cx="2468880" cy="4114800"/>
-          </a:xfrm>
-          <a:prstGeom prst="roundRect">
-            <a:avLst/>
-          </a:prstGeom>
-          <a:solidFill>
-            <a:srgbClr val="172A45"/>
-          </a:solidFill>
-          <a:ln w="19050">
-            <a:solidFill>
-              <a:srgbClr val="10B981"/>
-            </a:solidFill>
-          </a:ln>
-        </p:spPr>
-        <p:style>
-          <a:lnRef idx="1">
-            <a:schemeClr val="accent1"/>
-          </a:lnRef>
-          <a:fillRef idx="3">
-            <a:schemeClr val="accent1"/>
-          </a:fillRef>
-          <a:effectRef idx="2">
-            <a:schemeClr val="accent1"/>
-          </a:effectRef>
-          <a:fontRef idx="minor">
-            <a:schemeClr val="lt1"/>
-          </a:fontRef>
-        </p:style>
-        <p:txBody>
-          <a:bodyPr rtlCol="0" anchor="ctr"/>
-          <a:lstStyle/>
-          <a:p>
-            <a:pPr algn="ctr"/>
-          </a:p>
-        </p:txBody>
-      </p:sp>
-      <p:sp>
-        <p:nvSpPr>
-          <p:cNvPr id="13" name="TextBox 12"/>
-          <p:cNvSpPr txBox="1"/>
-          <p:nvPr/>
-        </p:nvSpPr>
-        <p:spPr>
-          <a:xfrm>
-            <a:off x="9052560" y="1828800"/>
-            <a:ext cx="2286000" cy="3749039"/>
-          </a:xfrm>
-          <a:prstGeom prst="rect">
-            <a:avLst/>
-          </a:prstGeom>
-          <a:noFill/>
-        </p:spPr>
-        <p:txBody>
-          <a:bodyPr wrap="square">
-            <a:spAutoFit/>
-          </a:bodyPr>
-          <a:lstStyle/>
-          <a:p>
-            <a:pPr>
-              <a:spcAft>
-                <a:spcPts val="400"/>
-              </a:spcAft>
-              <a:defRPr b="1" sz="1800">
-                <a:solidFill>
-                  <a:srgbClr val="10B981"/>
-                </a:solidFill>
-              </a:defRPr>
-            </a:pPr>
-            <a:r>
-              <a:t>GRAND FINALE</a:t>
-            </a:r>
-          </a:p>
-          <a:p>
-            <a:pPr>
-              <a:spcAft>
-                <a:spcPts val="1500"/>
-              </a:spcAft>
-              <a:defRPr i="1" sz="1200">
-                <a:solidFill>
-                  <a:srgbClr val="FFFFFF"/>
-                </a:solidFill>
-              </a:defRPr>
-            </a:pPr>
-            <a:r>
-              <a:t>June 27 - 28</a:t>
-            </a:r>
-          </a:p>
-          <a:p>
-            <a:pPr>
-              <a:defRPr sz="1200">
-                <a:solidFill>
-                  <a:srgbClr val="FFFFFF"/>
-                </a:solidFill>
-              </a:defRPr>
-            </a:pPr>
-            <a:r>
-              <a:t>• Deployment of final MERN app</a:t>
-            </a:r>
-            <a:br/>
-            <a:r>
-              <a:t>• Pitch presentation to expert jury</a:t>
-            </a:r>
-            <a:br/>
-            <a:r>
-              <a:t>• Q&amp;A &amp; Design defense</a:t>
-            </a:r>
-          </a:p>
-        </p:txBody>
-      </p:sp>
-      <p:sp>
-        <p:nvSpPr>
-          <p:cNvPr id="14" name="TextBox 13"/>
-          <p:cNvSpPr txBox="1"/>
-          <p:nvPr/>
-        </p:nvSpPr>
-        <p:spPr>
-          <a:xfrm>
-            <a:off x="731520" y="6035040"/>
-            <a:ext cx="10698480" cy="548640"/>
-          </a:xfrm>
-          <a:prstGeom prst="rect">
-            <a:avLst/>
-          </a:prstGeom>
-          <a:noFill/>
-        </p:spPr>
-        <p:txBody>
-          <a:bodyPr wrap="square">
-            <a:spAutoFit/>
-          </a:bodyPr>
-          <a:lstStyle/>
-          <a:p>
-            <a:pPr algn="ctr">
-              <a:defRPr sz="1100">
-                <a:solidFill>
-                  <a:srgbClr val="64748B"/>
-                </a:solidFill>
-              </a:defRPr>
-            </a:pPr>
-            <a:r>
-              <a:t>Bharat Academix CodeQuest 2026  |  Empowering academic excellence through modern, accessible AI systems.</a:t>
+              <a:t>• Inline SVG color matrix filters</a:t>
             </a:r>
           </a:p>
         </p:txBody>

</xml_diff>